<commit_message>
Base the presentation on all_operations.csv
</commit_message>
<xml_diff>
--- a/presentation/FinRadar.pptx
+++ b/presentation/FinRadar.pptx
@@ -120,7 +120,7 @@
   <p:extLst>
     <p:ext uri="{521415D9-36F7-43E2-AB2F-B90AF26B5E84}">
       <p14:sectionLst xmlns:p14="http://schemas.microsoft.com/office/powerpoint/2010/main">
-        <p14:section name="Выступление: 5 минут" id="{64fdd346-3286-d457-ab33-7cde511b991c}">
+        <p14:section name="Выступление: 5 минут" id="{2d5893b3-0f6d-189b-5c36-e4ca0bf89d15}">
           <p14:sldIdLst>
             <p14:sldId id="256"/>
             <p14:sldId id="257"/>
@@ -133,7 +133,7 @@
             <p14:sldId id="264"/>
           </p14:sldIdLst>
         </p14:section>
-        <p14:section name="Приложение: для вопросов" id="{a3121a94-22fa-e946-8398-fcb31ad975a5}">
+        <p14:section name="Приложение: для вопросов" id="{066a2c18-c759-71ac-6a43-c77bd12a7c45}">
           <p14:sldIdLst>
             <p14:sldId id="265"/>
             <p14:sldId id="266"/>
@@ -1250,7 +1250,7 @@
           <a:p>
             <a:r>
               <a:rPr lang="en-US" dirty="0"/>
-              <a:t>[1:15–1:45] Контрольный датасет загружаем на сайте как есть. Пример — компании test.csv кейса: 72 тысячи строк, 51 компания. Сервис сам распознаёт формат — с заголовком и без, строит прогноз по каждой компании, компанию выбираем в строке статуса. Из 51 компании 3 в критическом статусе, 6 — повышенный риск. На экране C124: 45 из 72 сценариев уводят остаток в минус, вероятность 62,5 процента.</a:t>
+              <a:t>[1:15–1:45] Контрольный датасет загружаем на сайте как есть. Пример — all_operations.csv: 222 тысячи строк, 150 компаний. Сервис сам распознаёт формат — с заголовком и без, строит прогноз по каждой компании, компанию выбираем в строке статуса. Из 150 компаний 17 в критическом статусе, 13 — повышенный риск. На экране C124: 45 из 72 сценариев уводят остаток в минус, вероятность 62,5 процента.</a:t>
             </a:r>
             <a:endParaRPr lang="en-US" dirty="0"/>
           </a:p>
@@ -1514,7 +1514,7 @@
           <a:p>
             <a:r>
               <a:rPr lang="en-US" dirty="0"/>
-              <a:t>[3:00–3:45] Точность остатка: MAE 1,17 млн ₽ против 1,23 млн ₽ у наивной модели — медиана с возвратом к обычному остатку немного точнее, RMSE 3,25 млн ₽, WAPE 25%. Сильная сторона — коридор: факт попадает между P10 и P90 в 77% случаев при ожидаемых 80. Вероятность: ROC-AUC 0,77 — рискованные компании модель ставит выше, разрыв видим в среднем за три недели. Но сама вероятность завышена: Brier 0,093 хуже постоянной 0,013 — это следующий шаг, калибровка. На наших и тестовых данных метрики близки: модель не подогнана под train.</a:t>
+              <a:t>[3:00–3:45] Точность остатка: MAE 1,17 млн ₽ против 1,23 млн ₽ у наивной модели — медиана с возвратом к обычному остатку немного точнее, RMSE 3,25 млн ₽, WAPE 25%. Сильная сторона — коридор: факт попадает между P10 и P90 в 77% случаев при ожидаемых 80. Вероятность: ROC-AUC 0,77 — рискованные компании модель ставит выше, разрыв видим в среднем за три недели. Но сама вероятность завышена: Brier 0,093 хуже постоянной 0,013 — это следующий шаг, калибровка. По всем шести датам среза картина одинаковая.</a:t>
             </a:r>
             <a:endParaRPr lang="en-US" dirty="0"/>
           </a:p>
@@ -1602,7 +1602,7 @@
           <a:p>
             <a:r>
               <a:rPr lang="en-US" dirty="0"/>
-              <a:t>[3:45–4:20] Для контрольного датасета есть одна команда: npm run evaluate с путём к файлу. Четыре шага: прогноз по каждой компании, бэктест со всеми метриками, графики и HTML-отчёт, который сразу открывается в браузере, интернет не нужен. На test.csv — пять секунд. Так жюри увидит и прогноз, и журнал, и матрицу ошибок на своём датасете.</a:t>
+              <a:t>[3:45–4:20] Для контрольного датасета есть одна команда: npm run evaluate с путём к файлу. Четыре шага: прогноз по каждой компании, бэктест со всеми метриками, графики и HTML-отчёт, который сразу открывается в браузере, интернет не нужен. На всех 150 компаниях — около десяти секунд. Так жюри увидит и прогноз, и журнал, и матрицу ошибок на своём датасете.</a:t>
             </a:r>
             <a:endParaRPr lang="en-US" dirty="0"/>
           </a:p>
@@ -5860,7 +5860,7 @@
                   <a:schemeClr val="tx2"/>
                 </a:solidFill>
               </a:rPr>
-              <a:t>Пример — компании test.csv кейса: 72 062 строки, 51 компания в одном файле</a:t>
+              <a:t>Пример — all_operations.csv: 222 420 строк, 150 компаний в одном файле</a:t>
             </a:r>
             <a:endParaRPr lang="en-US" sz="1800" dirty="0"/>
           </a:p>
@@ -5897,7 +5897,7 @@
       </p:sp>
       <p:pic>
         <p:nvPicPr>
-          <p:cNvPr id="5" name="Image 0" descr="Сайт после загрузки test.csv: выбрана компания C124, критический статус, прогнозный коридор">    </p:cNvPr>
+          <p:cNvPr id="5" name="Image 0" descr="Сайт после загрузки all_operations.csv: выбрана компания C124, критический статус, прогнозный коридор">    </p:cNvPr>
           <p:cNvPicPr>
             <a:picLocks noChangeAspect="1"/>
           </p:cNvPicPr>
@@ -5952,7 +5952,7 @@
                 <a:ea typeface="+mj-lt" pitchFamily="34" charset="-122"/>
                 <a:cs typeface="+mj-lt" pitchFamily="34" charset="-120"/>
               </a:rPr>
-              <a:t>51</a:t>
+              <a:t>150</a:t>
             </a:r>
             <a:endParaRPr lang="en-US" sz="4400" dirty="0"/>
           </a:p>
@@ -5966,7 +5966,7 @@
                   <a:schemeClr val="tx2"/>
                 </a:solidFill>
               </a:rPr>
-              <a:t>компания — прогноз по каждой; компания выбирается в строке статуса</a:t>
+              <a:t>компаний — прогноз по каждой; компания выбирается в строке статуса</a:t>
             </a:r>
             <a:endParaRPr lang="en-US" sz="4400" dirty="0"/>
           </a:p>
@@ -6027,7 +6027,7 @@
                 <a:ea typeface="+mj-lt" pitchFamily="34" charset="-122"/>
                 <a:cs typeface="+mj-lt" pitchFamily="34" charset="-120"/>
               </a:rPr>
-              <a:t>3</a:t>
+              <a:t>17</a:t>
             </a:r>
             <a:endParaRPr lang="en-US" sz="1800" dirty="0"/>
           </a:p>
@@ -6124,7 +6124,7 @@
                 <a:ea typeface="+mj-lt" pitchFamily="34" charset="-122"/>
                 <a:cs typeface="+mj-lt" pitchFamily="34" charset="-120"/>
               </a:rPr>
-              <a:t>6</a:t>
+              <a:t>13</a:t>
             </a:r>
             <a:endParaRPr lang="en-US" sz="1800" dirty="0"/>
           </a:p>
@@ -6221,7 +6221,7 @@
                 <a:ea typeface="+mj-lt" pitchFamily="34" charset="-122"/>
                 <a:cs typeface="+mj-lt" pitchFamily="34" charset="-120"/>
               </a:rPr>
-              <a:t>42</a:t>
+              <a:t>120</a:t>
             </a:r>
             <a:endParaRPr lang="en-US" sz="1800" dirty="0"/>
           </a:p>
@@ -7448,7 +7448,7 @@
                   <a:schemeClr val="tx2"/>
                 </a:solidFill>
               </a:rPr>
-              <a:t>Наши (train) и тестовые (test) данные — разные компании, а метрики близки</a:t>
+              <a:t>Бэктест на всех 150 компаниях: картина одинаковая на всех шести датах среза</a:t>
             </a:r>
             <a:endParaRPr lang="en-US" sz="1800" dirty="0"/>
           </a:p>
@@ -8214,19 +8214,15 @@
             <a:tbl>
               <a:tblPr/>
               <a:tblGrid>
-                <a:gridCol w="2011680"/>
-                <a:gridCol w="914400"/>
-                <a:gridCol w="868680"/>
-                <a:gridCol w="777240"/>
-                <a:gridCol w="914400"/>
-                <a:gridCol w="777240"/>
-                <a:gridCol w="914400"/>
-                <a:gridCol w="777240"/>
-                <a:gridCol w="1234440"/>
-                <a:gridCol w="868680"/>
-                <a:gridCol w="1033272"/>
+                <a:gridCol w="1463040"/>
+                <a:gridCol w="1280160"/>
+                <a:gridCol w="1463040"/>
+                <a:gridCol w="1554480"/>
+                <a:gridCol w="2377440"/>
+                <a:gridCol w="1463040"/>
+                <a:gridCol w="1490472"/>
               </a:tblGrid>
-              <a:tr h="384048">
+              <a:tr h="224028">
                 <a:tc>
                   <a:txBody>
                     <a:bodyPr/>
@@ -8236,17 +8232,17 @@
                         <a:buNone/>
                       </a:pPr>
                       <a:r>
-                        <a:rPr lang="en-US" sz="1300" b="1" dirty="0">
+                        <a:rPr lang="en-US" sz="1200" b="1" dirty="0">
                           <a:solidFill>
                             <a:schemeClr val="bg1"/>
                           </a:solidFill>
                         </a:rPr>
-                        <a:t>Данные</a:t>
+                        <a:t>Дата среза</a:t>
                       </a:r>
-                      <a:endParaRPr lang="en-US" sz="1300" dirty="0"/>
+                      <a:endParaRPr lang="en-US" sz="1200" dirty="0"/>
                     </a:p>
                   </a:txBody>
-                  <a:tcPr marL="50800" marR="50800" marT="25400" marB="25400" anchor="ctr">
+                  <a:tcPr marL="50800" marR="50800" marT="12700" marB="12700" anchor="ctr">
                     <a:lnL w="12700" cap="flat" cmpd="sng" algn="ctr">
                       <a:solidFill>
                         <a:schemeClr val="accent5"/>
@@ -8297,17 +8293,17 @@
                         <a:buNone/>
                       </a:pPr>
                       <a:r>
-                        <a:rPr lang="en-US" sz="1300" b="1" dirty="0">
+                        <a:rPr lang="en-US" sz="1200" b="1" dirty="0">
                           <a:solidFill>
                             <a:schemeClr val="bg1"/>
                           </a:solidFill>
                         </a:rPr>
                         <a:t>Прогнозов</a:t>
                       </a:r>
-                      <a:endParaRPr lang="en-US" sz="1300" dirty="0"/>
+                      <a:endParaRPr lang="en-US" sz="1200" dirty="0"/>
                     </a:p>
                   </a:txBody>
-                  <a:tcPr marL="50800" marR="50800" marT="25400" marB="25400" anchor="ctr">
+                  <a:tcPr marL="50800" marR="50800" marT="12700" marB="12700" anchor="ctr">
                     <a:lnL w="12700" cap="flat" cmpd="sng" algn="ctr">
                       <a:solidFill>
                         <a:schemeClr val="accent5"/>
@@ -8358,17 +8354,17 @@
                         <a:buNone/>
                       </a:pPr>
                       <a:r>
-                        <a:rPr lang="en-US" sz="1300" b="1" dirty="0">
+                        <a:rPr lang="en-US" sz="1200" b="1" dirty="0">
                           <a:solidFill>
                             <a:schemeClr val="bg1"/>
                           </a:solidFill>
                         </a:rPr>
-                        <a:t>Разрывов</a:t>
+                        <a:t>Уже в минусе</a:t>
                       </a:r>
-                      <a:endParaRPr lang="en-US" sz="1300" dirty="0"/>
+                      <a:endParaRPr lang="en-US" sz="1200" dirty="0"/>
                     </a:p>
                   </a:txBody>
-                  <a:tcPr marL="50800" marR="50800" marT="25400" marB="25400" anchor="ctr">
+                  <a:tcPr marL="50800" marR="50800" marT="12700" marB="12700" anchor="ctr">
                     <a:lnL w="12700" cap="flat" cmpd="sng" algn="ctr">
                       <a:solidFill>
                         <a:schemeClr val="accent5"/>
@@ -8419,17 +8415,17 @@
                         <a:buNone/>
                       </a:pPr>
                       <a:r>
-                        <a:rPr lang="en-US" sz="1300" b="1" dirty="0">
+                        <a:rPr lang="en-US" sz="1200" b="1" dirty="0">
                           <a:solidFill>
                             <a:schemeClr val="bg1"/>
                           </a:solidFill>
                         </a:rPr>
-                        <a:t>Recall</a:t>
+                        <a:t>Новых разрывов</a:t>
                       </a:r>
-                      <a:endParaRPr lang="en-US" sz="1300" dirty="0"/>
+                      <a:endParaRPr lang="en-US" sz="1200" dirty="0"/>
                     </a:p>
                   </a:txBody>
-                  <a:tcPr marL="50800" marR="50800" marT="25400" marB="25400" anchor="ctr">
+                  <a:tcPr marL="50800" marR="50800" marT="12700" marB="12700" anchor="ctr">
                     <a:lnL w="12700" cap="flat" cmpd="sng" algn="ctr">
                       <a:solidFill>
                         <a:schemeClr val="accent5"/>
@@ -8480,17 +8476,17 @@
                         <a:buNone/>
                       </a:pPr>
                       <a:r>
-                        <a:rPr lang="en-US" sz="1300" b="1" dirty="0">
+                        <a:rPr lang="en-US" sz="1200" b="1" dirty="0">
                           <a:solidFill>
                             <a:schemeClr val="bg1"/>
                           </a:solidFill>
                         </a:rPr>
-                        <a:t>Precision</a:t>
+                        <a:t>Сигналов «Повышенный риск»</a:t>
                       </a:r>
-                      <a:endParaRPr lang="en-US" sz="1300" dirty="0"/>
+                      <a:endParaRPr lang="en-US" sz="1200" dirty="0"/>
                     </a:p>
                   </a:txBody>
-                  <a:tcPr marL="50800" marR="50800" marT="25400" marB="25400" anchor="ctr">
+                  <a:tcPr marL="50800" marR="50800" marT="12700" marB="12700" anchor="ctr">
                     <a:lnL w="12700" cap="flat" cmpd="sng" algn="ctr">
                       <a:solidFill>
                         <a:schemeClr val="accent5"/>
@@ -8541,17 +8537,17 @@
                         <a:buNone/>
                       </a:pPr>
                       <a:r>
-                        <a:rPr lang="en-US" sz="1300" b="1" dirty="0">
+                        <a:rPr lang="en-US" sz="1200" b="1" dirty="0">
                           <a:solidFill>
                             <a:schemeClr val="bg1"/>
                           </a:solidFill>
                         </a:rPr>
-                        <a:t>F1</a:t>
+                        <a:t>Из них разрыв</a:t>
                       </a:r>
-                      <a:endParaRPr lang="en-US" sz="1300" dirty="0"/>
+                      <a:endParaRPr lang="en-US" sz="1200" dirty="0"/>
                     </a:p>
                   </a:txBody>
-                  <a:tcPr marL="50800" marR="50800" marT="25400" marB="25400" anchor="ctr">
+                  <a:tcPr marL="50800" marR="50800" marT="12700" marB="12700" anchor="ctr">
                     <a:lnL w="12700" cap="flat" cmpd="sng" algn="ctr">
                       <a:solidFill>
                         <a:schemeClr val="accent5"/>
@@ -8602,17 +8598,17 @@
                         <a:buNone/>
                       </a:pPr>
                       <a:r>
-                        <a:rPr lang="en-US" sz="1300" b="1" dirty="0">
+                        <a:rPr lang="en-US" sz="1200" b="1" dirty="0">
                           <a:solidFill>
                             <a:schemeClr val="bg1"/>
                           </a:solidFill>
                         </a:rPr>
-                        <a:t>ROC-AUC</a:t>
+                        <a:t>MAE P50</a:t>
                       </a:r>
-                      <a:endParaRPr lang="en-US" sz="1300" dirty="0"/>
+                      <a:endParaRPr lang="en-US" sz="1200" dirty="0"/>
                     </a:p>
                   </a:txBody>
-                  <a:tcPr marL="50800" marR="50800" marT="25400" marB="25400" anchor="ctr">
+                  <a:tcPr marL="50800" marR="50800" marT="12700" marB="12700" anchor="ctr">
                     <a:lnL w="12700" cap="flat" cmpd="sng" algn="ctr">
                       <a:solidFill>
                         <a:schemeClr val="accent5"/>
@@ -8654,6 +8650,8 @@
                     </a:solidFill>
                   </a:tcPr>
                 </a:tc>
+              </a:tr>
+              <a:tr h="224028">
                 <a:tc>
                   <a:txBody>
                     <a:bodyPr/>
@@ -8663,263 +8661,17 @@
                         <a:buNone/>
                       </a:pPr>
                       <a:r>
-                        <a:rPr lang="en-US" sz="1300" b="1" dirty="0">
-                          <a:solidFill>
-                            <a:schemeClr val="bg1"/>
-                          </a:solidFill>
-                        </a:rPr>
-                        <a:t>Brier</a:t>
-                      </a:r>
-                      <a:endParaRPr lang="en-US" sz="1300" dirty="0"/>
-                    </a:p>
-                  </a:txBody>
-                  <a:tcPr marL="50800" marR="50800" marT="25400" marB="25400" anchor="ctr">
-                    <a:lnL w="12700" cap="flat" cmpd="sng" algn="ctr">
-                      <a:solidFill>
-                        <a:schemeClr val="accent5"/>
-                      </a:solidFill>
-                      <a:prstDash val="solid"/>
-                      <a:round/>
-                      <a:headEnd type="none" w="med" len="med"/>
-                      <a:tailEnd type="none" w="med" len="med"/>
-                    </a:lnL>
-                    <a:lnR w="12700" cap="flat" cmpd="sng" algn="ctr">
-                      <a:solidFill>
-                        <a:schemeClr val="accent5"/>
-                      </a:solidFill>
-                      <a:prstDash val="solid"/>
-                      <a:round/>
-                      <a:headEnd type="none" w="med" len="med"/>
-                      <a:tailEnd type="none" w="med" len="med"/>
-                    </a:lnR>
-                    <a:lnT w="12700" cap="flat" cmpd="sng" algn="ctr">
-                      <a:solidFill>
-                        <a:schemeClr val="accent5"/>
-                      </a:solidFill>
-                      <a:prstDash val="solid"/>
-                      <a:round/>
-                      <a:headEnd type="none" w="med" len="med"/>
-                      <a:tailEnd type="none" w="med" len="med"/>
-                    </a:lnT>
-                    <a:lnB w="12700" cap="flat" cmpd="sng" algn="ctr">
-                      <a:solidFill>
-                        <a:schemeClr val="accent5"/>
-                      </a:solidFill>
-                      <a:prstDash val="solid"/>
-                      <a:round/>
-                      <a:headEnd type="none" w="med" len="med"/>
-                      <a:tailEnd type="none" w="med" len="med"/>
-                    </a:lnB>
-                    <a:solidFill>
-                      <a:schemeClr val="accent1"/>
-                    </a:solidFill>
-                  </a:tcPr>
-                </a:tc>
-                <a:tc>
-                  <a:txBody>
-                    <a:bodyPr/>
-                    <a:lstStyle/>
-                    <a:p>
-                      <a:pPr algn="ctr" indent="0" marL="0">
-                        <a:buNone/>
-                      </a:pPr>
-                      <a:r>
-                        <a:rPr lang="en-US" sz="1300" b="1" dirty="0">
-                          <a:solidFill>
-                            <a:schemeClr val="bg1"/>
-                          </a:solidFill>
-                        </a:rPr>
-                        <a:t>MAE</a:t>
-                      </a:r>
-                      <a:endParaRPr lang="en-US" sz="1300" dirty="0"/>
-                    </a:p>
-                  </a:txBody>
-                  <a:tcPr marL="50800" marR="50800" marT="25400" marB="25400" anchor="ctr">
-                    <a:lnL w="12700" cap="flat" cmpd="sng" algn="ctr">
-                      <a:solidFill>
-                        <a:schemeClr val="accent5"/>
-                      </a:solidFill>
-                      <a:prstDash val="solid"/>
-                      <a:round/>
-                      <a:headEnd type="none" w="med" len="med"/>
-                      <a:tailEnd type="none" w="med" len="med"/>
-                    </a:lnL>
-                    <a:lnR w="12700" cap="flat" cmpd="sng" algn="ctr">
-                      <a:solidFill>
-                        <a:schemeClr val="accent5"/>
-                      </a:solidFill>
-                      <a:prstDash val="solid"/>
-                      <a:round/>
-                      <a:headEnd type="none" w="med" len="med"/>
-                      <a:tailEnd type="none" w="med" len="med"/>
-                    </a:lnR>
-                    <a:lnT w="12700" cap="flat" cmpd="sng" algn="ctr">
-                      <a:solidFill>
-                        <a:schemeClr val="accent5"/>
-                      </a:solidFill>
-                      <a:prstDash val="solid"/>
-                      <a:round/>
-                      <a:headEnd type="none" w="med" len="med"/>
-                      <a:tailEnd type="none" w="med" len="med"/>
-                    </a:lnT>
-                    <a:lnB w="12700" cap="flat" cmpd="sng" algn="ctr">
-                      <a:solidFill>
-                        <a:schemeClr val="accent5"/>
-                      </a:solidFill>
-                      <a:prstDash val="solid"/>
-                      <a:round/>
-                      <a:headEnd type="none" w="med" len="med"/>
-                      <a:tailEnd type="none" w="med" len="med"/>
-                    </a:lnB>
-                    <a:solidFill>
-                      <a:schemeClr val="accent1"/>
-                    </a:solidFill>
-                  </a:tcPr>
-                </a:tc>
-                <a:tc>
-                  <a:txBody>
-                    <a:bodyPr/>
-                    <a:lstStyle/>
-                    <a:p>
-                      <a:pPr algn="ctr" indent="0" marL="0">
-                        <a:buNone/>
-                      </a:pPr>
-                      <a:r>
-                        <a:rPr lang="en-US" sz="1300" b="1" dirty="0">
-                          <a:solidFill>
-                            <a:schemeClr val="bg1"/>
-                          </a:solidFill>
-                        </a:rPr>
-                        <a:t>WAPE</a:t>
-                      </a:r>
-                      <a:endParaRPr lang="en-US" sz="1300" dirty="0"/>
-                    </a:p>
-                  </a:txBody>
-                  <a:tcPr marL="50800" marR="50800" marT="25400" marB="25400" anchor="ctr">
-                    <a:lnL w="12700" cap="flat" cmpd="sng" algn="ctr">
-                      <a:solidFill>
-                        <a:schemeClr val="accent5"/>
-                      </a:solidFill>
-                      <a:prstDash val="solid"/>
-                      <a:round/>
-                      <a:headEnd type="none" w="med" len="med"/>
-                      <a:tailEnd type="none" w="med" len="med"/>
-                    </a:lnL>
-                    <a:lnR w="12700" cap="flat" cmpd="sng" algn="ctr">
-                      <a:solidFill>
-                        <a:schemeClr val="accent5"/>
-                      </a:solidFill>
-                      <a:prstDash val="solid"/>
-                      <a:round/>
-                      <a:headEnd type="none" w="med" len="med"/>
-                      <a:tailEnd type="none" w="med" len="med"/>
-                    </a:lnR>
-                    <a:lnT w="12700" cap="flat" cmpd="sng" algn="ctr">
-                      <a:solidFill>
-                        <a:schemeClr val="accent5"/>
-                      </a:solidFill>
-                      <a:prstDash val="solid"/>
-                      <a:round/>
-                      <a:headEnd type="none" w="med" len="med"/>
-                      <a:tailEnd type="none" w="med" len="med"/>
-                    </a:lnT>
-                    <a:lnB w="12700" cap="flat" cmpd="sng" algn="ctr">
-                      <a:solidFill>
-                        <a:schemeClr val="accent5"/>
-                      </a:solidFill>
-                      <a:prstDash val="solid"/>
-                      <a:round/>
-                      <a:headEnd type="none" w="med" len="med"/>
-                      <a:tailEnd type="none" w="med" len="med"/>
-                    </a:lnB>
-                    <a:solidFill>
-                      <a:schemeClr val="accent1"/>
-                    </a:solidFill>
-                  </a:tcPr>
-                </a:tc>
-                <a:tc>
-                  <a:txBody>
-                    <a:bodyPr/>
-                    <a:lstStyle/>
-                    <a:p>
-                      <a:pPr algn="ctr" indent="0" marL="0">
-                        <a:buNone/>
-                      </a:pPr>
-                      <a:r>
-                        <a:rPr lang="en-US" sz="1300" b="1" dirty="0">
-                          <a:solidFill>
-                            <a:schemeClr val="bg1"/>
-                          </a:solidFill>
-                        </a:rPr>
-                        <a:t>P10–P90</a:t>
-                      </a:r>
-                      <a:endParaRPr lang="en-US" sz="1300" dirty="0"/>
-                    </a:p>
-                  </a:txBody>
-                  <a:tcPr marL="50800" marR="50800" marT="25400" marB="25400" anchor="ctr">
-                    <a:lnL w="12700" cap="flat" cmpd="sng" algn="ctr">
-                      <a:solidFill>
-                        <a:schemeClr val="accent5"/>
-                      </a:solidFill>
-                      <a:prstDash val="solid"/>
-                      <a:round/>
-                      <a:headEnd type="none" w="med" len="med"/>
-                      <a:tailEnd type="none" w="med" len="med"/>
-                    </a:lnL>
-                    <a:lnR w="12700" cap="flat" cmpd="sng" algn="ctr">
-                      <a:solidFill>
-                        <a:schemeClr val="accent5"/>
-                      </a:solidFill>
-                      <a:prstDash val="solid"/>
-                      <a:round/>
-                      <a:headEnd type="none" w="med" len="med"/>
-                      <a:tailEnd type="none" w="med" len="med"/>
-                    </a:lnR>
-                    <a:lnT w="12700" cap="flat" cmpd="sng" algn="ctr">
-                      <a:solidFill>
-                        <a:schemeClr val="accent5"/>
-                      </a:solidFill>
-                      <a:prstDash val="solid"/>
-                      <a:round/>
-                      <a:headEnd type="none" w="med" len="med"/>
-                      <a:tailEnd type="none" w="med" len="med"/>
-                    </a:lnT>
-                    <a:lnB w="12700" cap="flat" cmpd="sng" algn="ctr">
-                      <a:solidFill>
-                        <a:schemeClr val="accent5"/>
-                      </a:solidFill>
-                      <a:prstDash val="solid"/>
-                      <a:round/>
-                      <a:headEnd type="none" w="med" len="med"/>
-                      <a:tailEnd type="none" w="med" len="med"/>
-                    </a:lnB>
-                    <a:solidFill>
-                      <a:schemeClr val="accent1"/>
-                    </a:solidFill>
-                  </a:tcPr>
-                </a:tc>
-              </a:tr>
-              <a:tr h="384048">
-                <a:tc>
-                  <a:txBody>
-                    <a:bodyPr/>
-                    <a:lstStyle/>
-                    <a:p>
-                      <a:pPr algn="ctr" indent="0" marL="0">
-                        <a:buNone/>
-                      </a:pPr>
-                      <a:r>
-                        <a:rPr lang="en-US" sz="1300" dirty="0">
+                        <a:rPr lang="en-US" sz="1200" dirty="0">
                           <a:solidFill>
                             <a:schemeClr val="tx1"/>
                           </a:solidFill>
                         </a:rPr>
-                        <a:t>train.csv (наши)</a:t>
+                        <a:t>31.03.2026</a:t>
                       </a:r>
-                      <a:endParaRPr lang="en-US" sz="1300" dirty="0"/>
+                      <a:endParaRPr lang="en-US" sz="1200" dirty="0"/>
                     </a:p>
                   </a:txBody>
-                  <a:tcPr marL="50800" marR="50800" marT="25400" marB="25400" anchor="ctr">
+                  <a:tcPr marL="50800" marR="50800" marT="12700" marB="12700" anchor="ctr">
                     <a:lnL w="12700" cap="flat" cmpd="sng" algn="ctr">
                       <a:solidFill>
                         <a:schemeClr val="accent5"/>
@@ -8967,17 +8719,17 @@
                         <a:buNone/>
                       </a:pPr>
                       <a:r>
-                        <a:rPr lang="en-US" sz="1300" dirty="0">
+                        <a:rPr lang="en-US" sz="1200" dirty="0">
                           <a:solidFill>
                             <a:schemeClr val="tx1"/>
                           </a:solidFill>
                         </a:rPr>
-                        <a:t>519</a:t>
+                        <a:t>129</a:t>
                       </a:r>
-                      <a:endParaRPr lang="en-US" sz="1300" dirty="0"/>
+                      <a:endParaRPr lang="en-US" sz="1200" dirty="0"/>
                     </a:p>
                   </a:txBody>
-                  <a:tcPr marL="50800" marR="50800" marT="25400" marB="25400" anchor="ctr">
+                  <a:tcPr marL="50800" marR="50800" marT="12700" marB="12700" anchor="ctr">
                     <a:lnL w="12700" cap="flat" cmpd="sng" algn="ctr">
                       <a:solidFill>
                         <a:schemeClr val="accent5"/>
@@ -9025,17 +8777,17 @@
                         <a:buNone/>
                       </a:pPr>
                       <a:r>
-                        <a:rPr lang="en-US" sz="1300" dirty="0">
+                        <a:rPr lang="en-US" sz="1200" dirty="0">
                           <a:solidFill>
                             <a:schemeClr val="tx1"/>
                           </a:solidFill>
                         </a:rPr>
-                        <a:t>7</a:t>
+                        <a:t>4</a:t>
                       </a:r>
-                      <a:endParaRPr lang="en-US" sz="1300" dirty="0"/>
+                      <a:endParaRPr lang="en-US" sz="1200" dirty="0"/>
                     </a:p>
                   </a:txBody>
-                  <a:tcPr marL="50800" marR="50800" marT="25400" marB="25400" anchor="ctr">
+                  <a:tcPr marL="50800" marR="50800" marT="12700" marB="12700" anchor="ctr">
                     <a:lnL w="12700" cap="flat" cmpd="sng" algn="ctr">
                       <a:solidFill>
                         <a:schemeClr val="accent5"/>
@@ -9083,17 +8835,17 @@
                         <a:buNone/>
                       </a:pPr>
                       <a:r>
-                        <a:rPr lang="en-US" sz="1300" dirty="0">
+                        <a:rPr lang="en-US" sz="1200" dirty="0">
                           <a:solidFill>
                             <a:schemeClr val="tx1"/>
                           </a:solidFill>
                         </a:rPr>
-                        <a:t>0,71</a:t>
+                        <a:t>2</a:t>
                       </a:r>
-                      <a:endParaRPr lang="en-US" sz="1300" dirty="0"/>
+                      <a:endParaRPr lang="en-US" sz="1200" dirty="0"/>
                     </a:p>
                   </a:txBody>
-                  <a:tcPr marL="50800" marR="50800" marT="25400" marB="25400" anchor="ctr">
+                  <a:tcPr marL="50800" marR="50800" marT="12700" marB="12700" anchor="ctr">
                     <a:lnL w="12700" cap="flat" cmpd="sng" algn="ctr">
                       <a:solidFill>
                         <a:schemeClr val="accent5"/>
@@ -9141,17 +8893,17 @@
                         <a:buNone/>
                       </a:pPr>
                       <a:r>
-                        <a:rPr lang="en-US" sz="1300" dirty="0">
+                        <a:rPr lang="en-US" sz="1200" dirty="0">
                           <a:solidFill>
                             <a:schemeClr val="tx1"/>
                           </a:solidFill>
                         </a:rPr>
-                        <a:t>0,093</a:t>
+                        <a:t>13</a:t>
                       </a:r>
-                      <a:endParaRPr lang="en-US" sz="1300" dirty="0"/>
+                      <a:endParaRPr lang="en-US" sz="1200" dirty="0"/>
                     </a:p>
                   </a:txBody>
-                  <a:tcPr marL="50800" marR="50800" marT="25400" marB="25400" anchor="ctr">
+                  <a:tcPr marL="50800" marR="50800" marT="12700" marB="12700" anchor="ctr">
                     <a:lnL w="12700" cap="flat" cmpd="sng" algn="ctr">
                       <a:solidFill>
                         <a:schemeClr val="accent5"/>
@@ -9199,17 +8951,17 @@
                         <a:buNone/>
                       </a:pPr>
                       <a:r>
-                        <a:rPr lang="en-US" sz="1300" dirty="0">
+                        <a:rPr lang="en-US" sz="1200" dirty="0">
                           <a:solidFill>
                             <a:schemeClr val="tx1"/>
                           </a:solidFill>
                         </a:rPr>
-                        <a:t>0,164</a:t>
+                        <a:t>2</a:t>
                       </a:r>
-                      <a:endParaRPr lang="en-US" sz="1300" dirty="0"/>
+                      <a:endParaRPr lang="en-US" sz="1200" dirty="0"/>
                     </a:p>
                   </a:txBody>
-                  <a:tcPr marL="50800" marR="50800" marT="25400" marB="25400" anchor="ctr">
+                  <a:tcPr marL="50800" marR="50800" marT="12700" marB="12700" anchor="ctr">
                     <a:lnL w="12700" cap="flat" cmpd="sng" algn="ctr">
                       <a:solidFill>
                         <a:schemeClr val="accent5"/>
@@ -9257,17 +9009,77 @@
                         <a:buNone/>
                       </a:pPr>
                       <a:r>
-                        <a:rPr lang="en-US" sz="1300" dirty="0">
+                        <a:rPr lang="en-US" sz="1200" dirty="0">
                           <a:solidFill>
                             <a:schemeClr val="tx1"/>
                           </a:solidFill>
                         </a:rPr>
-                        <a:t>0,77</a:t>
+                        <a:t>1,01 млн ₽</a:t>
                       </a:r>
-                      <a:endParaRPr lang="en-US" sz="1300" dirty="0"/>
+                      <a:endParaRPr lang="en-US" sz="1200" dirty="0"/>
                     </a:p>
                   </a:txBody>
-                  <a:tcPr marL="50800" marR="50800" marT="25400" marB="25400" anchor="ctr">
+                  <a:tcPr marL="50800" marR="50800" marT="12700" marB="12700" anchor="ctr">
+                    <a:lnL w="12700" cap="flat" cmpd="sng" algn="ctr">
+                      <a:solidFill>
+                        <a:schemeClr val="accent5"/>
+                      </a:solidFill>
+                      <a:prstDash val="solid"/>
+                      <a:round/>
+                      <a:headEnd type="none" w="med" len="med"/>
+                      <a:tailEnd type="none" w="med" len="med"/>
+                    </a:lnL>
+                    <a:lnR w="12700" cap="flat" cmpd="sng" algn="ctr">
+                      <a:solidFill>
+                        <a:schemeClr val="accent5"/>
+                      </a:solidFill>
+                      <a:prstDash val="solid"/>
+                      <a:round/>
+                      <a:headEnd type="none" w="med" len="med"/>
+                      <a:tailEnd type="none" w="med" len="med"/>
+                    </a:lnR>
+                    <a:lnT w="12700" cap="flat" cmpd="sng" algn="ctr">
+                      <a:solidFill>
+                        <a:schemeClr val="accent5"/>
+                      </a:solidFill>
+                      <a:prstDash val="solid"/>
+                      <a:round/>
+                      <a:headEnd type="none" w="med" len="med"/>
+                      <a:tailEnd type="none" w="med" len="med"/>
+                    </a:lnT>
+                    <a:lnB w="12700" cap="flat" cmpd="sng" algn="ctr">
+                      <a:solidFill>
+                        <a:schemeClr val="accent5"/>
+                      </a:solidFill>
+                      <a:prstDash val="solid"/>
+                      <a:round/>
+                      <a:headEnd type="none" w="med" len="med"/>
+                      <a:tailEnd type="none" w="med" len="med"/>
+                    </a:lnB>
+                  </a:tcPr>
+                </a:tc>
+              </a:tr>
+              <a:tr h="224028">
+                <a:tc>
+                  <a:txBody>
+                    <a:bodyPr/>
+                    <a:lstStyle/>
+                    <a:p>
+                      <a:pPr algn="ctr" indent="0" marL="0">
+                        <a:buNone/>
+                      </a:pPr>
+                      <a:r>
+                        <a:rPr lang="en-US" sz="1200" dirty="0">
+                          <a:solidFill>
+                            <a:schemeClr val="tx1"/>
+                          </a:solidFill>
+                        </a:rPr>
+                        <a:t>30.04.2026</a:t>
+                      </a:r>
+                      <a:endParaRPr lang="en-US" sz="1200" dirty="0"/>
+                    </a:p>
+                  </a:txBody>
+                  <a:tcPr marL="50800" marR="50800" marT="12700" marB="12700" anchor="ctr">
                     <a:lnL w="12700" cap="flat" cmpd="sng" algn="ctr">
                       <a:solidFill>
                         <a:schemeClr val="accent5"/>
@@ -9315,17 +9127,17 @@
                         <a:buNone/>
                       </a:pPr>
                       <a:r>
-                        <a:rPr lang="en-US" sz="1300" dirty="0">
+                        <a:rPr lang="en-US" sz="1200" dirty="0">
                           <a:solidFill>
                             <a:schemeClr val="tx1"/>
                           </a:solidFill>
                         </a:rPr>
-                        <a:t>0,091</a:t>
+                        <a:t>130</a:t>
                       </a:r>
-                      <a:endParaRPr lang="en-US" sz="1300" dirty="0"/>
+                      <a:endParaRPr lang="en-US" sz="1200" dirty="0"/>
                     </a:p>
                   </a:txBody>
-                  <a:tcPr marL="50800" marR="50800" marT="25400" marB="25400" anchor="ctr">
+                  <a:tcPr marL="50800" marR="50800" marT="12700" marB="12700" anchor="ctr">
                     <a:lnL w="12700" cap="flat" cmpd="sng" algn="ctr">
                       <a:solidFill>
                         <a:schemeClr val="accent5"/>
@@ -9373,17 +9185,17 @@
                         <a:buNone/>
                       </a:pPr>
                       <a:r>
-                        <a:rPr lang="en-US" sz="1300" dirty="0">
+                        <a:rPr lang="en-US" sz="1200" dirty="0">
                           <a:solidFill>
                             <a:schemeClr val="tx1"/>
                           </a:solidFill>
                         </a:rPr>
-                        <a:t>1,42 млн ₽</a:t>
+                        <a:t>6</a:t>
                       </a:r>
-                      <a:endParaRPr lang="en-US" sz="1300" dirty="0"/>
+                      <a:endParaRPr lang="en-US" sz="1200" dirty="0"/>
                     </a:p>
                   </a:txBody>
-                  <a:tcPr marL="50800" marR="50800" marT="25400" marB="25400" anchor="ctr">
+                  <a:tcPr marL="50800" marR="50800" marT="12700" marB="12700" anchor="ctr">
                     <a:lnL w="12700" cap="flat" cmpd="sng" algn="ctr">
                       <a:solidFill>
                         <a:schemeClr val="accent5"/>
@@ -9431,17 +9243,17 @@
                         <a:buNone/>
                       </a:pPr>
                       <a:r>
-                        <a:rPr lang="en-US" sz="1300" dirty="0">
+                        <a:rPr lang="en-US" sz="1200" dirty="0">
                           <a:solidFill>
                             <a:schemeClr val="tx1"/>
                           </a:solidFill>
                         </a:rPr>
-                        <a:t>26,7%</a:t>
+                        <a:t>0</a:t>
                       </a:r>
-                      <a:endParaRPr lang="en-US" sz="1300" dirty="0"/>
+                      <a:endParaRPr lang="en-US" sz="1200" dirty="0"/>
                     </a:p>
                   </a:txBody>
-                  <a:tcPr marL="50800" marR="50800" marT="25400" marB="25400" anchor="ctr">
+                  <a:tcPr marL="50800" marR="50800" marT="12700" marB="12700" anchor="ctr">
                     <a:lnL w="12700" cap="flat" cmpd="sng" algn="ctr">
                       <a:solidFill>
                         <a:schemeClr val="accent5"/>
@@ -9489,77 +9301,17 @@
                         <a:buNone/>
                       </a:pPr>
                       <a:r>
-                        <a:rPr lang="en-US" sz="1300" dirty="0">
+                        <a:rPr lang="en-US" sz="1200" dirty="0">
                           <a:solidFill>
                             <a:schemeClr val="tx1"/>
                           </a:solidFill>
                         </a:rPr>
-                        <a:t>76,4%</a:t>
+                        <a:t>18</a:t>
                       </a:r>
-                      <a:endParaRPr lang="en-US" sz="1300" dirty="0"/>
+                      <a:endParaRPr lang="en-US" sz="1200" dirty="0"/>
                     </a:p>
                   </a:txBody>
-                  <a:tcPr marL="50800" marR="50800" marT="25400" marB="25400" anchor="ctr">
-                    <a:lnL w="12700" cap="flat" cmpd="sng" algn="ctr">
-                      <a:solidFill>
-                        <a:schemeClr val="accent5"/>
-                      </a:solidFill>
-                      <a:prstDash val="solid"/>
-                      <a:round/>
-                      <a:headEnd type="none" w="med" len="med"/>
-                      <a:tailEnd type="none" w="med" len="med"/>
-                    </a:lnL>
-                    <a:lnR w="12700" cap="flat" cmpd="sng" algn="ctr">
-                      <a:solidFill>
-                        <a:schemeClr val="accent5"/>
-                      </a:solidFill>
-                      <a:prstDash val="solid"/>
-                      <a:round/>
-                      <a:headEnd type="none" w="med" len="med"/>
-                      <a:tailEnd type="none" w="med" len="med"/>
-                    </a:lnR>
-                    <a:lnT w="12700" cap="flat" cmpd="sng" algn="ctr">
-                      <a:solidFill>
-                        <a:schemeClr val="accent5"/>
-                      </a:solidFill>
-                      <a:prstDash val="solid"/>
-                      <a:round/>
-                      <a:headEnd type="none" w="med" len="med"/>
-                      <a:tailEnd type="none" w="med" len="med"/>
-                    </a:lnT>
-                    <a:lnB w="12700" cap="flat" cmpd="sng" algn="ctr">
-                      <a:solidFill>
-                        <a:schemeClr val="accent5"/>
-                      </a:solidFill>
-                      <a:prstDash val="solid"/>
-                      <a:round/>
-                      <a:headEnd type="none" w="med" len="med"/>
-                      <a:tailEnd type="none" w="med" len="med"/>
-                    </a:lnB>
-                  </a:tcPr>
-                </a:tc>
-              </a:tr>
-              <a:tr h="384048">
-                <a:tc>
-                  <a:txBody>
-                    <a:bodyPr/>
-                    <a:lstStyle/>
-                    <a:p>
-                      <a:pPr algn="ctr" indent="0" marL="0">
-                        <a:buNone/>
-                      </a:pPr>
-                      <a:r>
-                        <a:rPr lang="en-US" sz="1300" dirty="0">
-                          <a:solidFill>
-                            <a:schemeClr val="tx1"/>
-                          </a:solidFill>
-                        </a:rPr>
-                        <a:t>test.csv (тестовые)</a:t>
-                      </a:r>
-                      <a:endParaRPr lang="en-US" sz="1300" dirty="0"/>
-                    </a:p>
-                  </a:txBody>
-                  <a:tcPr marL="50800" marR="50800" marT="25400" marB="25400" anchor="ctr">
+                  <a:tcPr marL="50800" marR="50800" marT="12700" marB="12700" anchor="ctr">
                     <a:lnL w="12700" cap="flat" cmpd="sng" algn="ctr">
                       <a:solidFill>
                         <a:schemeClr val="accent5"/>
@@ -9607,17 +9359,17 @@
                         <a:buNone/>
                       </a:pPr>
                       <a:r>
-                        <a:rPr lang="en-US" sz="1300" dirty="0">
+                        <a:rPr lang="en-US" sz="1200" dirty="0">
                           <a:solidFill>
                             <a:schemeClr val="tx1"/>
                           </a:solidFill>
                         </a:rPr>
-                        <a:t>274</a:t>
+                        <a:t>0</a:t>
                       </a:r>
-                      <a:endParaRPr lang="en-US" sz="1300" dirty="0"/>
+                      <a:endParaRPr lang="en-US" sz="1200" dirty="0"/>
                     </a:p>
                   </a:txBody>
-                  <a:tcPr marL="50800" marR="50800" marT="25400" marB="25400" anchor="ctr">
+                  <a:tcPr marL="50800" marR="50800" marT="12700" marB="12700" anchor="ctr">
                     <a:lnL w="12700" cap="flat" cmpd="sng" algn="ctr">
                       <a:solidFill>
                         <a:schemeClr val="accent5"/>
@@ -9665,17 +9417,77 @@
                         <a:buNone/>
                       </a:pPr>
                       <a:r>
-                        <a:rPr lang="en-US" sz="1300" dirty="0">
+                        <a:rPr lang="en-US" sz="1200" dirty="0">
                           <a:solidFill>
                             <a:schemeClr val="tx1"/>
                           </a:solidFill>
                         </a:rPr>
-                        <a:t>3</a:t>
+                        <a:t>0,92 млн ₽</a:t>
                       </a:r>
-                      <a:endParaRPr lang="en-US" sz="1300" dirty="0"/>
+                      <a:endParaRPr lang="en-US" sz="1200" dirty="0"/>
                     </a:p>
                   </a:txBody>
-                  <a:tcPr marL="50800" marR="50800" marT="25400" marB="25400" anchor="ctr">
+                  <a:tcPr marL="50800" marR="50800" marT="12700" marB="12700" anchor="ctr">
+                    <a:lnL w="12700" cap="flat" cmpd="sng" algn="ctr">
+                      <a:solidFill>
+                        <a:schemeClr val="accent5"/>
+                      </a:solidFill>
+                      <a:prstDash val="solid"/>
+                      <a:round/>
+                      <a:headEnd type="none" w="med" len="med"/>
+                      <a:tailEnd type="none" w="med" len="med"/>
+                    </a:lnL>
+                    <a:lnR w="12700" cap="flat" cmpd="sng" algn="ctr">
+                      <a:solidFill>
+                        <a:schemeClr val="accent5"/>
+                      </a:solidFill>
+                      <a:prstDash val="solid"/>
+                      <a:round/>
+                      <a:headEnd type="none" w="med" len="med"/>
+                      <a:tailEnd type="none" w="med" len="med"/>
+                    </a:lnR>
+                    <a:lnT w="12700" cap="flat" cmpd="sng" algn="ctr">
+                      <a:solidFill>
+                        <a:schemeClr val="accent5"/>
+                      </a:solidFill>
+                      <a:prstDash val="solid"/>
+                      <a:round/>
+                      <a:headEnd type="none" w="med" len="med"/>
+                      <a:tailEnd type="none" w="med" len="med"/>
+                    </a:lnT>
+                    <a:lnB w="12700" cap="flat" cmpd="sng" algn="ctr">
+                      <a:solidFill>
+                        <a:schemeClr val="accent5"/>
+                      </a:solidFill>
+                      <a:prstDash val="solid"/>
+                      <a:round/>
+                      <a:headEnd type="none" w="med" len="med"/>
+                      <a:tailEnd type="none" w="med" len="med"/>
+                    </a:lnB>
+                  </a:tcPr>
+                </a:tc>
+              </a:tr>
+              <a:tr h="224028">
+                <a:tc>
+                  <a:txBody>
+                    <a:bodyPr/>
+                    <a:lstStyle/>
+                    <a:p>
+                      <a:pPr algn="ctr" indent="0" marL="0">
+                        <a:buNone/>
+                      </a:pPr>
+                      <a:r>
+                        <a:rPr lang="en-US" sz="1200" dirty="0">
+                          <a:solidFill>
+                            <a:schemeClr val="tx1"/>
+                          </a:solidFill>
+                        </a:rPr>
+                        <a:t>31.05.2026</a:t>
+                      </a:r>
+                      <a:endParaRPr lang="en-US" sz="1200" dirty="0"/>
+                    </a:p>
+                  </a:txBody>
+                  <a:tcPr marL="50800" marR="50800" marT="12700" marB="12700" anchor="ctr">
                     <a:lnL w="12700" cap="flat" cmpd="sng" algn="ctr">
                       <a:solidFill>
                         <a:schemeClr val="accent5"/>
@@ -9723,17 +9535,17 @@
                         <a:buNone/>
                       </a:pPr>
                       <a:r>
-                        <a:rPr lang="en-US" sz="1300" dirty="0">
+                        <a:rPr lang="en-US" sz="1200" dirty="0">
                           <a:solidFill>
                             <a:schemeClr val="tx1"/>
                           </a:solidFill>
                         </a:rPr>
-                        <a:t>1,00</a:t>
+                        <a:t>131</a:t>
                       </a:r>
-                      <a:endParaRPr lang="en-US" sz="1300" dirty="0"/>
+                      <a:endParaRPr lang="en-US" sz="1200" dirty="0"/>
                     </a:p>
                   </a:txBody>
-                  <a:tcPr marL="50800" marR="50800" marT="25400" marB="25400" anchor="ctr">
+                  <a:tcPr marL="50800" marR="50800" marT="12700" marB="12700" anchor="ctr">
                     <a:lnL w="12700" cap="flat" cmpd="sng" algn="ctr">
                       <a:solidFill>
                         <a:schemeClr val="accent5"/>
@@ -9781,17 +9593,17 @@
                         <a:buNone/>
                       </a:pPr>
                       <a:r>
-                        <a:rPr lang="en-US" sz="1300" dirty="0">
+                        <a:rPr lang="en-US" sz="1200" dirty="0">
                           <a:solidFill>
                             <a:schemeClr val="tx1"/>
                           </a:solidFill>
                         </a:rPr>
-                        <a:t>0,103</a:t>
+                        <a:t>5</a:t>
                       </a:r>
-                      <a:endParaRPr lang="en-US" sz="1300" dirty="0"/>
+                      <a:endParaRPr lang="en-US" sz="1200" dirty="0"/>
                     </a:p>
                   </a:txBody>
-                  <a:tcPr marL="50800" marR="50800" marT="25400" marB="25400" anchor="ctr">
+                  <a:tcPr marL="50800" marR="50800" marT="12700" marB="12700" anchor="ctr">
                     <a:lnL w="12700" cap="flat" cmpd="sng" algn="ctr">
                       <a:solidFill>
                         <a:schemeClr val="accent5"/>
@@ -9839,17 +9651,17 @@
                         <a:buNone/>
                       </a:pPr>
                       <a:r>
-                        <a:rPr lang="en-US" sz="1300" dirty="0">
+                        <a:rPr lang="en-US" sz="1200" dirty="0">
                           <a:solidFill>
                             <a:schemeClr val="tx1"/>
                           </a:solidFill>
                         </a:rPr>
-                        <a:t>0,188</a:t>
+                        <a:t>1</a:t>
                       </a:r>
-                      <a:endParaRPr lang="en-US" sz="1300" dirty="0"/>
+                      <a:endParaRPr lang="en-US" sz="1200" dirty="0"/>
                     </a:p>
                   </a:txBody>
-                  <a:tcPr marL="50800" marR="50800" marT="25400" marB="25400" anchor="ctr">
+                  <a:tcPr marL="50800" marR="50800" marT="12700" marB="12700" anchor="ctr">
                     <a:lnL w="12700" cap="flat" cmpd="sng" algn="ctr">
                       <a:solidFill>
                         <a:schemeClr val="accent5"/>
@@ -9897,17 +9709,17 @@
                         <a:buNone/>
                       </a:pPr>
                       <a:r>
-                        <a:rPr lang="en-US" sz="1300" dirty="0">
+                        <a:rPr lang="en-US" sz="1200" dirty="0">
                           <a:solidFill>
                             <a:schemeClr val="tx1"/>
                           </a:solidFill>
                         </a:rPr>
-                        <a:t>0,79</a:t>
+                        <a:t>12</a:t>
                       </a:r>
-                      <a:endParaRPr lang="en-US" sz="1300" dirty="0"/>
+                      <a:endParaRPr lang="en-US" sz="1200" dirty="0"/>
                     </a:p>
                   </a:txBody>
-                  <a:tcPr marL="50800" marR="50800" marT="25400" marB="25400" anchor="ctr">
+                  <a:tcPr marL="50800" marR="50800" marT="12700" marB="12700" anchor="ctr">
                     <a:lnL w="12700" cap="flat" cmpd="sng" algn="ctr">
                       <a:solidFill>
                         <a:schemeClr val="accent5"/>
@@ -9955,17 +9767,17 @@
                         <a:buNone/>
                       </a:pPr>
                       <a:r>
-                        <a:rPr lang="en-US" sz="1300" dirty="0">
+                        <a:rPr lang="en-US" sz="1200" dirty="0">
                           <a:solidFill>
                             <a:schemeClr val="tx1"/>
                           </a:solidFill>
                         </a:rPr>
-                        <a:t>0,098</a:t>
+                        <a:t>1</a:t>
                       </a:r>
-                      <a:endParaRPr lang="en-US" sz="1300" dirty="0"/>
+                      <a:endParaRPr lang="en-US" sz="1200" dirty="0"/>
                     </a:p>
                   </a:txBody>
-                  <a:tcPr marL="50800" marR="50800" marT="25400" marB="25400" anchor="ctr">
+                  <a:tcPr marL="50800" marR="50800" marT="12700" marB="12700" anchor="ctr">
                     <a:lnL w="12700" cap="flat" cmpd="sng" algn="ctr">
                       <a:solidFill>
                         <a:schemeClr val="accent5"/>
@@ -10013,17 +9825,77 @@
                         <a:buNone/>
                       </a:pPr>
                       <a:r>
-                        <a:rPr lang="en-US" sz="1300" dirty="0">
+                        <a:rPr lang="en-US" sz="1200" dirty="0">
                           <a:solidFill>
                             <a:schemeClr val="tx1"/>
                           </a:solidFill>
                         </a:rPr>
-                        <a:t>0,68 млн ₽</a:t>
+                        <a:t>1,04 млн ₽</a:t>
                       </a:r>
-                      <a:endParaRPr lang="en-US" sz="1300" dirty="0"/>
+                      <a:endParaRPr lang="en-US" sz="1200" dirty="0"/>
                     </a:p>
                   </a:txBody>
-                  <a:tcPr marL="50800" marR="50800" marT="25400" marB="25400" anchor="ctr">
+                  <a:tcPr marL="50800" marR="50800" marT="12700" marB="12700" anchor="ctr">
+                    <a:lnL w="12700" cap="flat" cmpd="sng" algn="ctr">
+                      <a:solidFill>
+                        <a:schemeClr val="accent5"/>
+                      </a:solidFill>
+                      <a:prstDash val="solid"/>
+                      <a:round/>
+                      <a:headEnd type="none" w="med" len="med"/>
+                      <a:tailEnd type="none" w="med" len="med"/>
+                    </a:lnL>
+                    <a:lnR w="12700" cap="flat" cmpd="sng" algn="ctr">
+                      <a:solidFill>
+                        <a:schemeClr val="accent5"/>
+                      </a:solidFill>
+                      <a:prstDash val="solid"/>
+                      <a:round/>
+                      <a:headEnd type="none" w="med" len="med"/>
+                      <a:tailEnd type="none" w="med" len="med"/>
+                    </a:lnR>
+                    <a:lnT w="12700" cap="flat" cmpd="sng" algn="ctr">
+                      <a:solidFill>
+                        <a:schemeClr val="accent5"/>
+                      </a:solidFill>
+                      <a:prstDash val="solid"/>
+                      <a:round/>
+                      <a:headEnd type="none" w="med" len="med"/>
+                      <a:tailEnd type="none" w="med" len="med"/>
+                    </a:lnT>
+                    <a:lnB w="12700" cap="flat" cmpd="sng" algn="ctr">
+                      <a:solidFill>
+                        <a:schemeClr val="accent5"/>
+                      </a:solidFill>
+                      <a:prstDash val="solid"/>
+                      <a:round/>
+                      <a:headEnd type="none" w="med" len="med"/>
+                      <a:tailEnd type="none" w="med" len="med"/>
+                    </a:lnB>
+                  </a:tcPr>
+                </a:tc>
+              </a:tr>
+              <a:tr h="224028">
+                <a:tc>
+                  <a:txBody>
+                    <a:bodyPr/>
+                    <a:lstStyle/>
+                    <a:p>
+                      <a:pPr algn="ctr" indent="0" marL="0">
+                        <a:buNone/>
+                      </a:pPr>
+                      <a:r>
+                        <a:rPr lang="en-US" sz="1200" dirty="0">
+                          <a:solidFill>
+                            <a:schemeClr val="tx1"/>
+                          </a:solidFill>
+                        </a:rPr>
+                        <a:t>30.06.2026</a:t>
+                      </a:r>
+                      <a:endParaRPr lang="en-US" sz="1200" dirty="0"/>
+                    </a:p>
+                  </a:txBody>
+                  <a:tcPr marL="50800" marR="50800" marT="12700" marB="12700" anchor="ctr">
                     <a:lnL w="12700" cap="flat" cmpd="sng" algn="ctr">
                       <a:solidFill>
                         <a:schemeClr val="accent5"/>
@@ -10071,17 +9943,17 @@
                         <a:buNone/>
                       </a:pPr>
                       <a:r>
-                        <a:rPr lang="en-US" sz="1300" dirty="0">
+                        <a:rPr lang="en-US" sz="1200" dirty="0">
                           <a:solidFill>
                             <a:schemeClr val="tx1"/>
                           </a:solidFill>
                         </a:rPr>
-                        <a:t>21,2%</a:t>
+                        <a:t>131</a:t>
                       </a:r>
-                      <a:endParaRPr lang="en-US" sz="1300" dirty="0"/>
+                      <a:endParaRPr lang="en-US" sz="1200" dirty="0"/>
                     </a:p>
                   </a:txBody>
-                  <a:tcPr marL="50800" marR="50800" marT="25400" marB="25400" anchor="ctr">
+                  <a:tcPr marL="50800" marR="50800" marT="12700" marB="12700" anchor="ctr">
                     <a:lnL w="12700" cap="flat" cmpd="sng" algn="ctr">
                       <a:solidFill>
                         <a:schemeClr val="accent5"/>
@@ -10129,77 +10001,17 @@
                         <a:buNone/>
                       </a:pPr>
                       <a:r>
-                        <a:rPr lang="en-US" sz="1300" dirty="0">
+                        <a:rPr lang="en-US" sz="1200" dirty="0">
                           <a:solidFill>
                             <a:schemeClr val="tx1"/>
                           </a:solidFill>
                         </a:rPr>
-                        <a:t>77,8%</a:t>
+                        <a:t>6</a:t>
                       </a:r>
-                      <a:endParaRPr lang="en-US" sz="1300" dirty="0"/>
+                      <a:endParaRPr lang="en-US" sz="1200" dirty="0"/>
                     </a:p>
                   </a:txBody>
-                  <a:tcPr marL="50800" marR="50800" marT="25400" marB="25400" anchor="ctr">
-                    <a:lnL w="12700" cap="flat" cmpd="sng" algn="ctr">
-                      <a:solidFill>
-                        <a:schemeClr val="accent5"/>
-                      </a:solidFill>
-                      <a:prstDash val="solid"/>
-                      <a:round/>
-                      <a:headEnd type="none" w="med" len="med"/>
-                      <a:tailEnd type="none" w="med" len="med"/>
-                    </a:lnL>
-                    <a:lnR w="12700" cap="flat" cmpd="sng" algn="ctr">
-                      <a:solidFill>
-                        <a:schemeClr val="accent5"/>
-                      </a:solidFill>
-                      <a:prstDash val="solid"/>
-                      <a:round/>
-                      <a:headEnd type="none" w="med" len="med"/>
-                      <a:tailEnd type="none" w="med" len="med"/>
-                    </a:lnR>
-                    <a:lnT w="12700" cap="flat" cmpd="sng" algn="ctr">
-                      <a:solidFill>
-                        <a:schemeClr val="accent5"/>
-                      </a:solidFill>
-                      <a:prstDash val="solid"/>
-                      <a:round/>
-                      <a:headEnd type="none" w="med" len="med"/>
-                      <a:tailEnd type="none" w="med" len="med"/>
-                    </a:lnT>
-                    <a:lnB w="12700" cap="flat" cmpd="sng" algn="ctr">
-                      <a:solidFill>
-                        <a:schemeClr val="accent5"/>
-                      </a:solidFill>
-                      <a:prstDash val="solid"/>
-                      <a:round/>
-                      <a:headEnd type="none" w="med" len="med"/>
-                      <a:tailEnd type="none" w="med" len="med"/>
-                    </a:lnB>
-                  </a:tcPr>
-                </a:tc>
-              </a:tr>
-              <a:tr h="384048">
-                <a:tc>
-                  <a:txBody>
-                    <a:bodyPr/>
-                    <a:lstStyle/>
-                    <a:p>
-                      <a:pPr algn="ctr" indent="0" marL="0">
-                        <a:buNone/>
-                      </a:pPr>
-                      <a:r>
-                        <a:rPr lang="en-US" sz="1300" b="1" dirty="0">
-                          <a:solidFill>
-                            <a:schemeClr val="tx1"/>
-                          </a:solidFill>
-                        </a:rPr>
-                        <a:t>Все вместе</a:t>
-                      </a:r>
-                      <a:endParaRPr lang="en-US" sz="1300" dirty="0"/>
-                    </a:p>
-                  </a:txBody>
-                  <a:tcPr marL="50800" marR="50800" marT="25400" marB="25400" anchor="ctr">
+                  <a:tcPr marL="50800" marR="50800" marT="12700" marB="12700" anchor="ctr">
                     <a:lnL w="12700" cap="flat" cmpd="sng" algn="ctr">
                       <a:solidFill>
                         <a:schemeClr val="accent5"/>
@@ -10247,17 +10059,17 @@
                         <a:buNone/>
                       </a:pPr>
                       <a:r>
-                        <a:rPr lang="en-US" sz="1300" b="1" dirty="0">
+                        <a:rPr lang="en-US" sz="1200" dirty="0">
                           <a:solidFill>
                             <a:schemeClr val="tx1"/>
                           </a:solidFill>
                         </a:rPr>
-                        <a:t>793</a:t>
+                        <a:t>2</a:t>
                       </a:r>
-                      <a:endParaRPr lang="en-US" sz="1300" dirty="0"/>
+                      <a:endParaRPr lang="en-US" sz="1200" dirty="0"/>
                     </a:p>
                   </a:txBody>
-                  <a:tcPr marL="50800" marR="50800" marT="25400" marB="25400" anchor="ctr">
+                  <a:tcPr marL="50800" marR="50800" marT="12700" marB="12700" anchor="ctr">
                     <a:lnL w="12700" cap="flat" cmpd="sng" algn="ctr">
                       <a:solidFill>
                         <a:schemeClr val="accent5"/>
@@ -10305,17 +10117,17 @@
                         <a:buNone/>
                       </a:pPr>
                       <a:r>
-                        <a:rPr lang="en-US" sz="1300" b="1" dirty="0">
+                        <a:rPr lang="en-US" sz="1200" dirty="0">
                           <a:solidFill>
                             <a:schemeClr val="tx1"/>
                           </a:solidFill>
                         </a:rPr>
-                        <a:t>10</a:t>
+                        <a:t>11</a:t>
                       </a:r>
-                      <a:endParaRPr lang="en-US" sz="1300" dirty="0"/>
+                      <a:endParaRPr lang="en-US" sz="1200" dirty="0"/>
                     </a:p>
                   </a:txBody>
-                  <a:tcPr marL="50800" marR="50800" marT="25400" marB="25400" anchor="ctr">
+                  <a:tcPr marL="50800" marR="50800" marT="12700" marB="12700" anchor="ctr">
                     <a:lnL w="12700" cap="flat" cmpd="sng" algn="ctr">
                       <a:solidFill>
                         <a:schemeClr val="accent5"/>
@@ -10363,17 +10175,17 @@
                         <a:buNone/>
                       </a:pPr>
                       <a:r>
-                        <a:rPr lang="en-US" sz="1300" b="1" dirty="0">
+                        <a:rPr lang="en-US" sz="1200" dirty="0">
                           <a:solidFill>
                             <a:schemeClr val="tx1"/>
                           </a:solidFill>
                         </a:rPr>
-                        <a:t>0,80</a:t>
+                        <a:t>1</a:t>
                       </a:r>
-                      <a:endParaRPr lang="en-US" sz="1300" dirty="0"/>
+                      <a:endParaRPr lang="en-US" sz="1200" dirty="0"/>
                     </a:p>
                   </a:txBody>
-                  <a:tcPr marL="50800" marR="50800" marT="25400" marB="25400" anchor="ctr">
+                  <a:tcPr marL="50800" marR="50800" marT="12700" marB="12700" anchor="ctr">
                     <a:lnL w="12700" cap="flat" cmpd="sng" algn="ctr">
                       <a:solidFill>
                         <a:schemeClr val="accent5"/>
@@ -10421,17 +10233,77 @@
                         <a:buNone/>
                       </a:pPr>
                       <a:r>
-                        <a:rPr lang="en-US" sz="1300" b="1" dirty="0">
+                        <a:rPr lang="en-US" sz="1200" dirty="0">
                           <a:solidFill>
                             <a:schemeClr val="tx1"/>
                           </a:solidFill>
                         </a:rPr>
-                        <a:t>0,096</a:t>
+                        <a:t>1,39 млн ₽</a:t>
                       </a:r>
-                      <a:endParaRPr lang="en-US" sz="1300" dirty="0"/>
+                      <a:endParaRPr lang="en-US" sz="1200" dirty="0"/>
                     </a:p>
                   </a:txBody>
-                  <a:tcPr marL="50800" marR="50800" marT="25400" marB="25400" anchor="ctr">
+                  <a:tcPr marL="50800" marR="50800" marT="12700" marB="12700" anchor="ctr">
+                    <a:lnL w="12700" cap="flat" cmpd="sng" algn="ctr">
+                      <a:solidFill>
+                        <a:schemeClr val="accent5"/>
+                      </a:solidFill>
+                      <a:prstDash val="solid"/>
+                      <a:round/>
+                      <a:headEnd type="none" w="med" len="med"/>
+                      <a:tailEnd type="none" w="med" len="med"/>
+                    </a:lnL>
+                    <a:lnR w="12700" cap="flat" cmpd="sng" algn="ctr">
+                      <a:solidFill>
+                        <a:schemeClr val="accent5"/>
+                      </a:solidFill>
+                      <a:prstDash val="solid"/>
+                      <a:round/>
+                      <a:headEnd type="none" w="med" len="med"/>
+                      <a:tailEnd type="none" w="med" len="med"/>
+                    </a:lnR>
+                    <a:lnT w="12700" cap="flat" cmpd="sng" algn="ctr">
+                      <a:solidFill>
+                        <a:schemeClr val="accent5"/>
+                      </a:solidFill>
+                      <a:prstDash val="solid"/>
+                      <a:round/>
+                      <a:headEnd type="none" w="med" len="med"/>
+                      <a:tailEnd type="none" w="med" len="med"/>
+                    </a:lnT>
+                    <a:lnB w="12700" cap="flat" cmpd="sng" algn="ctr">
+                      <a:solidFill>
+                        <a:schemeClr val="accent5"/>
+                      </a:solidFill>
+                      <a:prstDash val="solid"/>
+                      <a:round/>
+                      <a:headEnd type="none" w="med" len="med"/>
+                      <a:tailEnd type="none" w="med" len="med"/>
+                    </a:lnB>
+                  </a:tcPr>
+                </a:tc>
+              </a:tr>
+              <a:tr h="224028">
+                <a:tc>
+                  <a:txBody>
+                    <a:bodyPr/>
+                    <a:lstStyle/>
+                    <a:p>
+                      <a:pPr algn="ctr" indent="0" marL="0">
+                        <a:buNone/>
+                      </a:pPr>
+                      <a:r>
+                        <a:rPr lang="en-US" sz="1200" dirty="0">
+                          <a:solidFill>
+                            <a:schemeClr val="tx1"/>
+                          </a:solidFill>
+                        </a:rPr>
+                        <a:t>31.07.2026</a:t>
+                      </a:r>
+                      <a:endParaRPr lang="en-US" sz="1200" dirty="0"/>
+                    </a:p>
+                  </a:txBody>
+                  <a:tcPr marL="50800" marR="50800" marT="12700" marB="12700" anchor="ctr">
                     <a:lnL w="12700" cap="flat" cmpd="sng" algn="ctr">
                       <a:solidFill>
                         <a:schemeClr val="accent5"/>
@@ -10479,17 +10351,17 @@
                         <a:buNone/>
                       </a:pPr>
                       <a:r>
-                        <a:rPr lang="en-US" sz="1300" b="1" dirty="0">
+                        <a:rPr lang="en-US" sz="1200" dirty="0">
                           <a:solidFill>
                             <a:schemeClr val="tx1"/>
                           </a:solidFill>
                         </a:rPr>
-                        <a:t>0,172</a:t>
+                        <a:t>135</a:t>
                       </a:r>
-                      <a:endParaRPr lang="en-US" sz="1300" dirty="0"/>
+                      <a:endParaRPr lang="en-US" sz="1200" dirty="0"/>
                     </a:p>
                   </a:txBody>
-                  <a:tcPr marL="50800" marR="50800" marT="25400" marB="25400" anchor="ctr">
+                  <a:tcPr marL="50800" marR="50800" marT="12700" marB="12700" anchor="ctr">
                     <a:lnL w="12700" cap="flat" cmpd="sng" algn="ctr">
                       <a:solidFill>
                         <a:schemeClr val="accent5"/>
@@ -10537,17 +10409,17 @@
                         <a:buNone/>
                       </a:pPr>
                       <a:r>
-                        <a:rPr lang="en-US" sz="1300" b="1" dirty="0">
+                        <a:rPr lang="en-US" sz="1200" dirty="0">
                           <a:solidFill>
                             <a:schemeClr val="tx1"/>
                           </a:solidFill>
                         </a:rPr>
-                        <a:t>0,77</a:t>
+                        <a:t>6</a:t>
                       </a:r>
-                      <a:endParaRPr lang="en-US" sz="1300" dirty="0"/>
+                      <a:endParaRPr lang="en-US" sz="1200" dirty="0"/>
                     </a:p>
                   </a:txBody>
-                  <a:tcPr marL="50800" marR="50800" marT="25400" marB="25400" anchor="ctr">
+                  <a:tcPr marL="50800" marR="50800" marT="12700" marB="12700" anchor="ctr">
                     <a:lnL w="12700" cap="flat" cmpd="sng" algn="ctr">
                       <a:solidFill>
                         <a:schemeClr val="accent5"/>
@@ -10595,17 +10467,17 @@
                         <a:buNone/>
                       </a:pPr>
                       <a:r>
-                        <a:rPr lang="en-US" sz="1300" b="1" dirty="0">
+                        <a:rPr lang="en-US" sz="1200" dirty="0">
                           <a:solidFill>
                             <a:schemeClr val="tx1"/>
                           </a:solidFill>
                         </a:rPr>
-                        <a:t>0,093</a:t>
+                        <a:t>2</a:t>
                       </a:r>
-                      <a:endParaRPr lang="en-US" sz="1300" dirty="0"/>
+                      <a:endParaRPr lang="en-US" sz="1200" dirty="0"/>
                     </a:p>
                   </a:txBody>
-                  <a:tcPr marL="50800" marR="50800" marT="25400" marB="25400" anchor="ctr">
+                  <a:tcPr marL="50800" marR="50800" marT="12700" marB="12700" anchor="ctr">
                     <a:lnL w="12700" cap="flat" cmpd="sng" algn="ctr">
                       <a:solidFill>
                         <a:schemeClr val="accent5"/>
@@ -10653,17 +10525,17 @@
                         <a:buNone/>
                       </a:pPr>
                       <a:r>
-                        <a:rPr lang="en-US" sz="1300" b="1" dirty="0">
+                        <a:rPr lang="en-US" sz="1200" dirty="0">
                           <a:solidFill>
                             <a:schemeClr val="tx1"/>
                           </a:solidFill>
                         </a:rPr>
-                        <a:t>1,17 млн ₽</a:t>
+                        <a:t>20</a:t>
                       </a:r>
-                      <a:endParaRPr lang="en-US" sz="1300" dirty="0"/>
+                      <a:endParaRPr lang="en-US" sz="1200" dirty="0"/>
                     </a:p>
                   </a:txBody>
-                  <a:tcPr marL="50800" marR="50800" marT="25400" marB="25400" anchor="ctr">
+                  <a:tcPr marL="50800" marR="50800" marT="12700" marB="12700" anchor="ctr">
                     <a:lnL w="12700" cap="flat" cmpd="sng" algn="ctr">
                       <a:solidFill>
                         <a:schemeClr val="accent5"/>
@@ -10711,17 +10583,17 @@
                         <a:buNone/>
                       </a:pPr>
                       <a:r>
-                        <a:rPr lang="en-US" sz="1300" b="1" dirty="0">
+                        <a:rPr lang="en-US" sz="1200" dirty="0">
                           <a:solidFill>
                             <a:schemeClr val="tx1"/>
                           </a:solidFill>
                         </a:rPr>
-                        <a:t>25,3%</a:t>
+                        <a:t>2</a:t>
                       </a:r>
-                      <a:endParaRPr lang="en-US" sz="1300" dirty="0"/>
+                      <a:endParaRPr lang="en-US" sz="1200" dirty="0"/>
                     </a:p>
                   </a:txBody>
-                  <a:tcPr marL="50800" marR="50800" marT="25400" marB="25400" anchor="ctr">
+                  <a:tcPr marL="50800" marR="50800" marT="12700" marB="12700" anchor="ctr">
                     <a:lnL w="12700" cap="flat" cmpd="sng" algn="ctr">
                       <a:solidFill>
                         <a:schemeClr val="accent5"/>
@@ -10769,17 +10641,425 @@
                         <a:buNone/>
                       </a:pPr>
                       <a:r>
-                        <a:rPr lang="en-US" sz="1300" b="1" dirty="0">
+                        <a:rPr lang="en-US" sz="1200" dirty="0">
                           <a:solidFill>
                             <a:schemeClr val="tx1"/>
                           </a:solidFill>
                         </a:rPr>
-                        <a:t>76,9%</a:t>
+                        <a:t>1,44 млн ₽</a:t>
                       </a:r>
-                      <a:endParaRPr lang="en-US" sz="1300" dirty="0"/>
+                      <a:endParaRPr lang="en-US" sz="1200" dirty="0"/>
                     </a:p>
                   </a:txBody>
-                  <a:tcPr marL="50800" marR="50800" marT="25400" marB="25400" anchor="ctr">
+                  <a:tcPr marL="50800" marR="50800" marT="12700" marB="12700" anchor="ctr">
+                    <a:lnL w="12700" cap="flat" cmpd="sng" algn="ctr">
+                      <a:solidFill>
+                        <a:schemeClr val="accent5"/>
+                      </a:solidFill>
+                      <a:prstDash val="solid"/>
+                      <a:round/>
+                      <a:headEnd type="none" w="med" len="med"/>
+                      <a:tailEnd type="none" w="med" len="med"/>
+                    </a:lnL>
+                    <a:lnR w="12700" cap="flat" cmpd="sng" algn="ctr">
+                      <a:solidFill>
+                        <a:schemeClr val="accent5"/>
+                      </a:solidFill>
+                      <a:prstDash val="solid"/>
+                      <a:round/>
+                      <a:headEnd type="none" w="med" len="med"/>
+                      <a:tailEnd type="none" w="med" len="med"/>
+                    </a:lnR>
+                    <a:lnT w="12700" cap="flat" cmpd="sng" algn="ctr">
+                      <a:solidFill>
+                        <a:schemeClr val="accent5"/>
+                      </a:solidFill>
+                      <a:prstDash val="solid"/>
+                      <a:round/>
+                      <a:headEnd type="none" w="med" len="med"/>
+                      <a:tailEnd type="none" w="med" len="med"/>
+                    </a:lnT>
+                    <a:lnB w="12700" cap="flat" cmpd="sng" algn="ctr">
+                      <a:solidFill>
+                        <a:schemeClr val="accent5"/>
+                      </a:solidFill>
+                      <a:prstDash val="solid"/>
+                      <a:round/>
+                      <a:headEnd type="none" w="med" len="med"/>
+                      <a:tailEnd type="none" w="med" len="med"/>
+                    </a:lnB>
+                  </a:tcPr>
+                </a:tc>
+              </a:tr>
+              <a:tr h="224028">
+                <a:tc>
+                  <a:txBody>
+                    <a:bodyPr/>
+                    <a:lstStyle/>
+                    <a:p>
+                      <a:pPr algn="ctr" indent="0" marL="0">
+                        <a:buNone/>
+                      </a:pPr>
+                      <a:r>
+                        <a:rPr lang="en-US" sz="1200" dirty="0">
+                          <a:solidFill>
+                            <a:schemeClr val="tx1"/>
+                          </a:solidFill>
+                        </a:rPr>
+                        <a:t>31.08.2026</a:t>
+                      </a:r>
+                      <a:endParaRPr lang="en-US" sz="1200" dirty="0"/>
+                    </a:p>
+                  </a:txBody>
+                  <a:tcPr marL="50800" marR="50800" marT="12700" marB="12700" anchor="ctr">
+                    <a:lnL w="12700" cap="flat" cmpd="sng" algn="ctr">
+                      <a:solidFill>
+                        <a:schemeClr val="accent5"/>
+                      </a:solidFill>
+                      <a:prstDash val="solid"/>
+                      <a:round/>
+                      <a:headEnd type="none" w="med" len="med"/>
+                      <a:tailEnd type="none" w="med" len="med"/>
+                    </a:lnL>
+                    <a:lnR w="12700" cap="flat" cmpd="sng" algn="ctr">
+                      <a:solidFill>
+                        <a:schemeClr val="accent5"/>
+                      </a:solidFill>
+                      <a:prstDash val="solid"/>
+                      <a:round/>
+                      <a:headEnd type="none" w="med" len="med"/>
+                      <a:tailEnd type="none" w="med" len="med"/>
+                    </a:lnR>
+                    <a:lnT w="12700" cap="flat" cmpd="sng" algn="ctr">
+                      <a:solidFill>
+                        <a:schemeClr val="accent5"/>
+                      </a:solidFill>
+                      <a:prstDash val="solid"/>
+                      <a:round/>
+                      <a:headEnd type="none" w="med" len="med"/>
+                      <a:tailEnd type="none" w="med" len="med"/>
+                    </a:lnT>
+                    <a:lnB w="12700" cap="flat" cmpd="sng" algn="ctr">
+                      <a:solidFill>
+                        <a:schemeClr val="accent5"/>
+                      </a:solidFill>
+                      <a:prstDash val="solid"/>
+                      <a:round/>
+                      <a:headEnd type="none" w="med" len="med"/>
+                      <a:tailEnd type="none" w="med" len="med"/>
+                    </a:lnB>
+                  </a:tcPr>
+                </a:tc>
+                <a:tc>
+                  <a:txBody>
+                    <a:bodyPr/>
+                    <a:lstStyle/>
+                    <a:p>
+                      <a:pPr algn="ctr" indent="0" marL="0">
+                        <a:buNone/>
+                      </a:pPr>
+                      <a:r>
+                        <a:rPr lang="en-US" sz="1200" dirty="0">
+                          <a:solidFill>
+                            <a:schemeClr val="tx1"/>
+                          </a:solidFill>
+                        </a:rPr>
+                        <a:t>137</a:t>
+                      </a:r>
+                      <a:endParaRPr lang="en-US" sz="1200" dirty="0"/>
+                    </a:p>
+                  </a:txBody>
+                  <a:tcPr marL="50800" marR="50800" marT="12700" marB="12700" anchor="ctr">
+                    <a:lnL w="12700" cap="flat" cmpd="sng" algn="ctr">
+                      <a:solidFill>
+                        <a:schemeClr val="accent5"/>
+                      </a:solidFill>
+                      <a:prstDash val="solid"/>
+                      <a:round/>
+                      <a:headEnd type="none" w="med" len="med"/>
+                      <a:tailEnd type="none" w="med" len="med"/>
+                    </a:lnL>
+                    <a:lnR w="12700" cap="flat" cmpd="sng" algn="ctr">
+                      <a:solidFill>
+                        <a:schemeClr val="accent5"/>
+                      </a:solidFill>
+                      <a:prstDash val="solid"/>
+                      <a:round/>
+                      <a:headEnd type="none" w="med" len="med"/>
+                      <a:tailEnd type="none" w="med" len="med"/>
+                    </a:lnR>
+                    <a:lnT w="12700" cap="flat" cmpd="sng" algn="ctr">
+                      <a:solidFill>
+                        <a:schemeClr val="accent5"/>
+                      </a:solidFill>
+                      <a:prstDash val="solid"/>
+                      <a:round/>
+                      <a:headEnd type="none" w="med" len="med"/>
+                      <a:tailEnd type="none" w="med" len="med"/>
+                    </a:lnT>
+                    <a:lnB w="12700" cap="flat" cmpd="sng" algn="ctr">
+                      <a:solidFill>
+                        <a:schemeClr val="accent5"/>
+                      </a:solidFill>
+                      <a:prstDash val="solid"/>
+                      <a:round/>
+                      <a:headEnd type="none" w="med" len="med"/>
+                      <a:tailEnd type="none" w="med" len="med"/>
+                    </a:lnB>
+                  </a:tcPr>
+                </a:tc>
+                <a:tc>
+                  <a:txBody>
+                    <a:bodyPr/>
+                    <a:lstStyle/>
+                    <a:p>
+                      <a:pPr algn="ctr" indent="0" marL="0">
+                        <a:buNone/>
+                      </a:pPr>
+                      <a:r>
+                        <a:rPr lang="en-US" sz="1200" dirty="0">
+                          <a:solidFill>
+                            <a:schemeClr val="tx1"/>
+                          </a:solidFill>
+                        </a:rPr>
+                        <a:t>5</a:t>
+                      </a:r>
+                      <a:endParaRPr lang="en-US" sz="1200" dirty="0"/>
+                    </a:p>
+                  </a:txBody>
+                  <a:tcPr marL="50800" marR="50800" marT="12700" marB="12700" anchor="ctr">
+                    <a:lnL w="12700" cap="flat" cmpd="sng" algn="ctr">
+                      <a:solidFill>
+                        <a:schemeClr val="accent5"/>
+                      </a:solidFill>
+                      <a:prstDash val="solid"/>
+                      <a:round/>
+                      <a:headEnd type="none" w="med" len="med"/>
+                      <a:tailEnd type="none" w="med" len="med"/>
+                    </a:lnL>
+                    <a:lnR w="12700" cap="flat" cmpd="sng" algn="ctr">
+                      <a:solidFill>
+                        <a:schemeClr val="accent5"/>
+                      </a:solidFill>
+                      <a:prstDash val="solid"/>
+                      <a:round/>
+                      <a:headEnd type="none" w="med" len="med"/>
+                      <a:tailEnd type="none" w="med" len="med"/>
+                    </a:lnR>
+                    <a:lnT w="12700" cap="flat" cmpd="sng" algn="ctr">
+                      <a:solidFill>
+                        <a:schemeClr val="accent5"/>
+                      </a:solidFill>
+                      <a:prstDash val="solid"/>
+                      <a:round/>
+                      <a:headEnd type="none" w="med" len="med"/>
+                      <a:tailEnd type="none" w="med" len="med"/>
+                    </a:lnT>
+                    <a:lnB w="12700" cap="flat" cmpd="sng" algn="ctr">
+                      <a:solidFill>
+                        <a:schemeClr val="accent5"/>
+                      </a:solidFill>
+                      <a:prstDash val="solid"/>
+                      <a:round/>
+                      <a:headEnd type="none" w="med" len="med"/>
+                      <a:tailEnd type="none" w="med" len="med"/>
+                    </a:lnB>
+                  </a:tcPr>
+                </a:tc>
+                <a:tc>
+                  <a:txBody>
+                    <a:bodyPr/>
+                    <a:lstStyle/>
+                    <a:p>
+                      <a:pPr algn="ctr" indent="0" marL="0">
+                        <a:buNone/>
+                      </a:pPr>
+                      <a:r>
+                        <a:rPr lang="en-US" sz="1200" dirty="0">
+                          <a:solidFill>
+                            <a:schemeClr val="tx1"/>
+                          </a:solidFill>
+                        </a:rPr>
+                        <a:t>3</a:t>
+                      </a:r>
+                      <a:endParaRPr lang="en-US" sz="1200" dirty="0"/>
+                    </a:p>
+                  </a:txBody>
+                  <a:tcPr marL="50800" marR="50800" marT="12700" marB="12700" anchor="ctr">
+                    <a:lnL w="12700" cap="flat" cmpd="sng" algn="ctr">
+                      <a:solidFill>
+                        <a:schemeClr val="accent5"/>
+                      </a:solidFill>
+                      <a:prstDash val="solid"/>
+                      <a:round/>
+                      <a:headEnd type="none" w="med" len="med"/>
+                      <a:tailEnd type="none" w="med" len="med"/>
+                    </a:lnL>
+                    <a:lnR w="12700" cap="flat" cmpd="sng" algn="ctr">
+                      <a:solidFill>
+                        <a:schemeClr val="accent5"/>
+                      </a:solidFill>
+                      <a:prstDash val="solid"/>
+                      <a:round/>
+                      <a:headEnd type="none" w="med" len="med"/>
+                      <a:tailEnd type="none" w="med" len="med"/>
+                    </a:lnR>
+                    <a:lnT w="12700" cap="flat" cmpd="sng" algn="ctr">
+                      <a:solidFill>
+                        <a:schemeClr val="accent5"/>
+                      </a:solidFill>
+                      <a:prstDash val="solid"/>
+                      <a:round/>
+                      <a:headEnd type="none" w="med" len="med"/>
+                      <a:tailEnd type="none" w="med" len="med"/>
+                    </a:lnT>
+                    <a:lnB w="12700" cap="flat" cmpd="sng" algn="ctr">
+                      <a:solidFill>
+                        <a:schemeClr val="accent5"/>
+                      </a:solidFill>
+                      <a:prstDash val="solid"/>
+                      <a:round/>
+                      <a:headEnd type="none" w="med" len="med"/>
+                      <a:tailEnd type="none" w="med" len="med"/>
+                    </a:lnB>
+                  </a:tcPr>
+                </a:tc>
+                <a:tc>
+                  <a:txBody>
+                    <a:bodyPr/>
+                    <a:lstStyle/>
+                    <a:p>
+                      <a:pPr algn="ctr" indent="0" marL="0">
+                        <a:buNone/>
+                      </a:pPr>
+                      <a:r>
+                        <a:rPr lang="en-US" sz="1200" dirty="0">
+                          <a:solidFill>
+                            <a:schemeClr val="tx1"/>
+                          </a:solidFill>
+                        </a:rPr>
+                        <a:t>9</a:t>
+                      </a:r>
+                      <a:endParaRPr lang="en-US" sz="1200" dirty="0"/>
+                    </a:p>
+                  </a:txBody>
+                  <a:tcPr marL="50800" marR="50800" marT="12700" marB="12700" anchor="ctr">
+                    <a:lnL w="12700" cap="flat" cmpd="sng" algn="ctr">
+                      <a:solidFill>
+                        <a:schemeClr val="accent5"/>
+                      </a:solidFill>
+                      <a:prstDash val="solid"/>
+                      <a:round/>
+                      <a:headEnd type="none" w="med" len="med"/>
+                      <a:tailEnd type="none" w="med" len="med"/>
+                    </a:lnL>
+                    <a:lnR w="12700" cap="flat" cmpd="sng" algn="ctr">
+                      <a:solidFill>
+                        <a:schemeClr val="accent5"/>
+                      </a:solidFill>
+                      <a:prstDash val="solid"/>
+                      <a:round/>
+                      <a:headEnd type="none" w="med" len="med"/>
+                      <a:tailEnd type="none" w="med" len="med"/>
+                    </a:lnR>
+                    <a:lnT w="12700" cap="flat" cmpd="sng" algn="ctr">
+                      <a:solidFill>
+                        <a:schemeClr val="accent5"/>
+                      </a:solidFill>
+                      <a:prstDash val="solid"/>
+                      <a:round/>
+                      <a:headEnd type="none" w="med" len="med"/>
+                      <a:tailEnd type="none" w="med" len="med"/>
+                    </a:lnT>
+                    <a:lnB w="12700" cap="flat" cmpd="sng" algn="ctr">
+                      <a:solidFill>
+                        <a:schemeClr val="accent5"/>
+                      </a:solidFill>
+                      <a:prstDash val="solid"/>
+                      <a:round/>
+                      <a:headEnd type="none" w="med" len="med"/>
+                      <a:tailEnd type="none" w="med" len="med"/>
+                    </a:lnB>
+                  </a:tcPr>
+                </a:tc>
+                <a:tc>
+                  <a:txBody>
+                    <a:bodyPr/>
+                    <a:lstStyle/>
+                    <a:p>
+                      <a:pPr algn="ctr" indent="0" marL="0">
+                        <a:buNone/>
+                      </a:pPr>
+                      <a:r>
+                        <a:rPr lang="en-US" sz="1200" dirty="0">
+                          <a:solidFill>
+                            <a:schemeClr val="tx1"/>
+                          </a:solidFill>
+                        </a:rPr>
+                        <a:t>2</a:t>
+                      </a:r>
+                      <a:endParaRPr lang="en-US" sz="1200" dirty="0"/>
+                    </a:p>
+                  </a:txBody>
+                  <a:tcPr marL="50800" marR="50800" marT="12700" marB="12700" anchor="ctr">
+                    <a:lnL w="12700" cap="flat" cmpd="sng" algn="ctr">
+                      <a:solidFill>
+                        <a:schemeClr val="accent5"/>
+                      </a:solidFill>
+                      <a:prstDash val="solid"/>
+                      <a:round/>
+                      <a:headEnd type="none" w="med" len="med"/>
+                      <a:tailEnd type="none" w="med" len="med"/>
+                    </a:lnL>
+                    <a:lnR w="12700" cap="flat" cmpd="sng" algn="ctr">
+                      <a:solidFill>
+                        <a:schemeClr val="accent5"/>
+                      </a:solidFill>
+                      <a:prstDash val="solid"/>
+                      <a:round/>
+                      <a:headEnd type="none" w="med" len="med"/>
+                      <a:tailEnd type="none" w="med" len="med"/>
+                    </a:lnR>
+                    <a:lnT w="12700" cap="flat" cmpd="sng" algn="ctr">
+                      <a:solidFill>
+                        <a:schemeClr val="accent5"/>
+                      </a:solidFill>
+                      <a:prstDash val="solid"/>
+                      <a:round/>
+                      <a:headEnd type="none" w="med" len="med"/>
+                      <a:tailEnd type="none" w="med" len="med"/>
+                    </a:lnT>
+                    <a:lnB w="12700" cap="flat" cmpd="sng" algn="ctr">
+                      <a:solidFill>
+                        <a:schemeClr val="accent5"/>
+                      </a:solidFill>
+                      <a:prstDash val="solid"/>
+                      <a:round/>
+                      <a:headEnd type="none" w="med" len="med"/>
+                      <a:tailEnd type="none" w="med" len="med"/>
+                    </a:lnB>
+                  </a:tcPr>
+                </a:tc>
+                <a:tc>
+                  <a:txBody>
+                    <a:bodyPr/>
+                    <a:lstStyle/>
+                    <a:p>
+                      <a:pPr algn="ctr" indent="0" marL="0">
+                        <a:buNone/>
+                      </a:pPr>
+                      <a:r>
+                        <a:rPr lang="en-US" sz="1200" dirty="0">
+                          <a:solidFill>
+                            <a:schemeClr val="tx1"/>
+                          </a:solidFill>
+                        </a:rPr>
+                        <a:t>1,19 млн ₽</a:t>
+                      </a:r>
+                      <a:endParaRPr lang="en-US" sz="1200" dirty="0"/>
+                    </a:p>
+                  </a:txBody>
+                  <a:tcPr marL="50800" marR="50800" marT="12700" marB="12700" anchor="ctr">
                     <a:lnL w="12700" cap="flat" cmpd="sng" algn="ctr">
                       <a:solidFill>
                         <a:schemeClr val="accent5"/>
@@ -10831,8 +11111,8 @@
         </p:nvSpPr>
         <p:spPr>
           <a:xfrm>
-            <a:off x="548640" y="5943600"/>
-            <a:ext cx="11094415" cy="320040"/>
+            <a:off x="548640" y="6016752"/>
+            <a:ext cx="11094415" cy="274320"/>
           </a:xfrm>
           <a:prstGeom prst="rect">
             <a:avLst/>
@@ -10853,7 +11133,7 @@
                   <a:schemeClr val="tx2"/>
                 </a:solidFill>
               </a:rPr>
-              <a:t>Recall, Precision, F1 — для статуса «Повышенный риск»: вероятность ≥ 10%, у компаний без минуса за год — ≥ 60%</a:t>
+              <a:t>«Повышенный риск»: вероятность ≥ 10%, у компаний без минуса за год — ≥ 60%</a:t>
             </a:r>
             <a:endParaRPr lang="en-US" sz="1200" dirty="0"/>
           </a:p>
@@ -11549,7 +11829,7 @@
                   <a:schemeClr val="tx2"/>
                 </a:solidFill>
               </a:rPr>
-              <a:t>Отчёт по test.csv: 51 компания, около 5 секунд</a:t>
+              <a:t>Отчёт по all_operations.csv: 150 компаний, около 10 секунд</a:t>
             </a:r>
             <a:endParaRPr lang="en-US" sz="1300" dirty="0"/>
           </a:p>
@@ -11912,7 +12192,7 @@
                 <a:ea typeface="+mj-lt" pitchFamily="34" charset="-122"/>
                 <a:cs typeface="+mj-lt" pitchFamily="34" charset="-120"/>
               </a:rPr>
-              <a:t>51</a:t>
+              <a:t>150</a:t>
             </a:r>
             <a:endParaRPr lang="en-US" sz="3200" dirty="0"/>
           </a:p>
@@ -11948,7 +12228,7 @@
                   <a:schemeClr val="accent5"/>
                 </a:solidFill>
               </a:rPr>
-              <a:t>компания: прогноз и журнал из одного файла за ~5 секунд</a:t>
+              <a:t>компаний: прогноз и журнал из одного файла за ~10 секунд</a:t>
             </a:r>
             <a:endParaRPr lang="en-US" sz="1500" dirty="0"/>
           </a:p>

</xml_diff>

<commit_message>
Show the confusion matrix, MAE/RMSE, lead time and P10-P90 charts in the appendix
The ROC / calibration and precision-recall charts are dropped from the
appendix, and its table of contents is numbered from slide 11.
</commit_message>
<xml_diff>
--- a/presentation/FinRadar.pptx
+++ b/presentation/FinRadar.pptx
@@ -120,7 +120,7 @@
   <p:extLst>
     <p:ext uri="{521415D9-36F7-43E2-AB2F-B90AF26B5E84}">
       <p14:sectionLst xmlns:p14="http://schemas.microsoft.com/office/powerpoint/2010/main">
-        <p14:section name="Выступление: 5 минут" id="{2d5893b3-0f6d-189b-5c36-e4ca0bf89d15}">
+        <p14:section name="Выступление: 5 минут" id="{15d1519f-b3da-3f8e-6241-9f821814cba5}">
           <p14:sldIdLst>
             <p14:sldId id="256"/>
             <p14:sldId id="257"/>
@@ -133,7 +133,7 @@
             <p14:sldId id="264"/>
           </p14:sldIdLst>
         </p14:section>
-        <p14:section name="Приложение: для вопросов" id="{066a2c18-c759-71ac-6a43-c77bd12a7c45}">
+        <p14:section name="Приложение: для вопросов" id="{acb0064b-4c0b-d67f-f919-5917d2f0de34}">
           <p14:sldIdLst>
             <p14:sldId id="265"/>
             <p14:sldId id="266"/>
@@ -722,7 +722,7 @@
           <a:p>
             <a:r>
               <a:rPr lang="en-US" dirty="0"/>
-              <a:t>ROC-AUC 0,773. Калибровка: в группе с вероятностью от 50% в среднем обещано 72%, разрыв случился в 5,1%. Отсюда Brier 0,0932 против 0,0130 у константы.</a:t>
+              <a:t>TP / FP / FN / TN: «Повышенный риск» 8 / 75 / 2 / 676, «Критический» 4 / 35 / 6 / 716. Accuracy 0,899 и 0,946, F1 0,172 и 0,163.</a:t>
             </a:r>
             <a:endParaRPr lang="en-US" dirty="0"/>
           </a:p>
@@ -810,7 +810,7 @@
           <a:p>
             <a:r>
               <a:rPr lang="en-US" dirty="0"/>
-              <a:t>Порог 10% — статус «Повышенный риск», 50% — «Критический». Precision выше случайного угадывания на всех порогах, но остаётся низким: разрывы редкие.</a:t>
+              <a:t>MAE в первый день 0,18 млн ₽, на 30-й — 1,62 млн ₽. Наивная модель: MAE 1,23 млн ₽, тренд — 1,36 млн ₽.</a:t>
             </a:r>
             <a:endParaRPr lang="en-US" dirty="0"/>
           </a:p>
@@ -898,7 +898,7 @@
           <a:p>
             <a:r>
               <a:rPr lang="en-US" dirty="0"/>
-              <a:t>MAE в первый день 0,18 млн ₽, на 30-й — 1,62 млн ₽.</a:t>
+              <a:t>Найденные статусом «Повышенный риск» разрывы: 1, 5, 15, 18, 25, 28, 28, 30 дней от прогноза.</a:t>
             </a:r>
             <a:endParaRPr lang="en-US" dirty="0"/>
           </a:p>
@@ -986,7 +986,7 @@
           <a:p>
             <a:r>
               <a:rPr lang="en-US" dirty="0"/>
-              <a:t>Найденные статусом «Повышенный риск» разрывы: 1, 5, 15, 18, 25, 28, 28, 30 дней от прогноза. Коридор P10–P90 держится около 75–80% на всём горизонте.</a:t>
+              <a:t>Ниже P10 — 8,4% точек, выше P90 — 14,7%. Коридор держится около 75–80% на всём горизонте.</a:t>
             </a:r>
             <a:endParaRPr lang="en-US" dirty="0"/>
           </a:p>
@@ -2920,7 +2920,7 @@
                 <a:ea typeface="+mj-lt" pitchFamily="34" charset="-122"/>
                 <a:cs typeface="+mj-lt" pitchFamily="34" charset="-120"/>
               </a:rPr>
-              <a:t>10</a:t>
+              <a:t>11</a:t>
             </a:r>
             <a:endParaRPr lang="en-US" sz="1600" dirty="0"/>
           </a:p>
@@ -2956,7 +2956,7 @@
                   <a:schemeClr val="bg1"/>
                 </a:solidFill>
               </a:rPr>
-              <a:t>ROC-кривая и калибровка вероятности</a:t>
+              <a:t>Матрица ошибок статусов</a:t>
             </a:r>
             <a:endParaRPr lang="en-US" sz="2000" dirty="0"/>
           </a:p>
@@ -2993,103 +2993,6 @@
         <p:spPr>
           <a:xfrm>
             <a:off x="548640" y="3383280"/>
-            <a:ext cx="548640" cy="548640"/>
-          </a:xfrm>
-          <a:prstGeom prst="rect">
-            <a:avLst/>
-          </a:prstGeom>
-          <a:noFill/>
-          <a:ln/>
-        </p:spPr>
-        <p:txBody>
-          <a:bodyPr wrap="square" lIns="0" tIns="0" rIns="0" bIns="0" rtlCol="0" anchor="ctr"/>
-          <a:lstStyle/>
-          <a:p>
-            <a:pPr algn="ctr" indent="0" marL="0">
-              <a:buNone/>
-            </a:pPr>
-            <a:r>
-              <a:rPr lang="en-US" sz="1600" b="1" dirty="0">
-                <a:solidFill>
-                  <a:schemeClr val="accent5"/>
-                </a:solidFill>
-                <a:latin typeface="+mj-lt" pitchFamily="34" charset="0"/>
-                <a:ea typeface="+mj-lt" pitchFamily="34" charset="-122"/>
-                <a:cs typeface="+mj-lt" pitchFamily="34" charset="-120"/>
-              </a:rPr>
-              <a:t>11</a:t>
-            </a:r>
-            <a:endParaRPr lang="en-US" sz="1600" dirty="0"/>
-          </a:p>
-        </p:txBody>
-      </p:sp>
-      <p:sp>
-        <p:nvSpPr>
-          <p:cNvPr id="9" name="Text 7"/>
-          <p:cNvSpPr txBox="1"/>
-          <p:nvPr/>
-        </p:nvSpPr>
-        <p:spPr>
-          <a:xfrm>
-            <a:off x="1325880" y="3383280"/>
-            <a:ext cx="10317175" cy="548640"/>
-          </a:xfrm>
-          <a:prstGeom prst="rect">
-            <a:avLst/>
-          </a:prstGeom>
-          <a:noFill/>
-          <a:ln/>
-        </p:spPr>
-        <p:txBody>
-          <a:bodyPr wrap="square" lIns="0" tIns="0" rIns="0" bIns="0" rtlCol="0" anchor="ctr"/>
-          <a:lstStyle/>
-          <a:p>
-            <a:pPr indent="0" marL="0">
-              <a:buNone/>
-            </a:pPr>
-            <a:r>
-              <a:rPr lang="en-US" sz="2000" dirty="0">
-                <a:solidFill>
-                  <a:schemeClr val="bg1"/>
-                </a:solidFill>
-              </a:rPr>
-              <a:t>Precision и Recall по порогу вероятности</a:t>
-            </a:r>
-            <a:endParaRPr lang="en-US" sz="2000" dirty="0"/>
-          </a:p>
-        </p:txBody>
-      </p:sp>
-      <p:sp>
-        <p:nvSpPr>
-          <p:cNvPr id="10" name="appendix-n-2"/>
-          <p:cNvSpPr/>
-          <p:nvPr/>
-        </p:nvSpPr>
-        <p:spPr>
-          <a:xfrm>
-            <a:off x="548640" y="4160520"/>
-            <a:ext cx="548640" cy="548640"/>
-          </a:xfrm>
-          <a:prstGeom prst="roundRect">
-            <a:avLst>
-              <a:gd name="adj" fmla="val 16667"/>
-            </a:avLst>
-          </a:prstGeom>
-          <a:solidFill>
-            <a:schemeClr val="accent6"/>
-          </a:solidFill>
-          <a:ln/>
-        </p:spPr>
-      </p:sp>
-      <p:sp>
-        <p:nvSpPr>
-          <p:cNvPr id="11" name="Text 9"/>
-          <p:cNvSpPr txBox="1"/>
-          <p:nvPr/>
-        </p:nvSpPr>
-        <p:spPr>
-          <a:xfrm>
-            <a:off x="548640" y="4160520"/>
             <a:ext cx="548640" cy="548640"/>
           </a:xfrm>
           <a:prstGeom prst="rect">
@@ -3122,13 +3025,13 @@
       </p:sp>
       <p:sp>
         <p:nvSpPr>
-          <p:cNvPr id="12" name="Text 10"/>
+          <p:cNvPr id="9" name="Text 7"/>
           <p:cNvSpPr txBox="1"/>
           <p:nvPr/>
         </p:nvSpPr>
         <p:spPr>
           <a:xfrm>
-            <a:off x="1325880" y="4160520"/>
+            <a:off x="1325880" y="3383280"/>
             <a:ext cx="10317175" cy="548640"/>
           </a:xfrm>
           <a:prstGeom prst="rect">
@@ -3158,13 +3061,13 @@
       </p:sp>
       <p:sp>
         <p:nvSpPr>
-          <p:cNvPr id="13" name="appendix-n-3"/>
+          <p:cNvPr id="10" name="appendix-n-2"/>
           <p:cNvSpPr/>
           <p:nvPr/>
         </p:nvSpPr>
         <p:spPr>
           <a:xfrm>
-            <a:off x="548640" y="4937760"/>
+            <a:off x="548640" y="4160520"/>
             <a:ext cx="548640" cy="548640"/>
           </a:xfrm>
           <a:prstGeom prst="roundRect">
@@ -3180,13 +3083,13 @@
       </p:sp>
       <p:sp>
         <p:nvSpPr>
-          <p:cNvPr id="14" name="Text 12"/>
+          <p:cNvPr id="11" name="Text 9"/>
           <p:cNvSpPr txBox="1"/>
           <p:nvPr/>
         </p:nvSpPr>
         <p:spPr>
           <a:xfrm>
-            <a:off x="548640" y="4937760"/>
+            <a:off x="548640" y="4160520"/>
             <a:ext cx="548640" cy="548640"/>
           </a:xfrm>
           <a:prstGeom prst="rect">
@@ -3219,6 +3122,103 @@
       </p:sp>
       <p:sp>
         <p:nvSpPr>
+          <p:cNvPr id="12" name="Text 10"/>
+          <p:cNvSpPr txBox="1"/>
+          <p:nvPr/>
+        </p:nvSpPr>
+        <p:spPr>
+          <a:xfrm>
+            <a:off x="1325880" y="4160520"/>
+            <a:ext cx="10317175" cy="548640"/>
+          </a:xfrm>
+          <a:prstGeom prst="rect">
+            <a:avLst/>
+          </a:prstGeom>
+          <a:noFill/>
+          <a:ln/>
+        </p:spPr>
+        <p:txBody>
+          <a:bodyPr wrap="square" lIns="0" tIns="0" rIns="0" bIns="0" rtlCol="0" anchor="ctr"/>
+          <a:lstStyle/>
+          <a:p>
+            <a:pPr indent="0" marL="0">
+              <a:buNone/>
+            </a:pPr>
+            <a:r>
+              <a:rPr lang="en-US" sz="2000" dirty="0">
+                <a:solidFill>
+                  <a:schemeClr val="bg1"/>
+                </a:solidFill>
+              </a:rPr>
+              <a:t>Заблаговременность предупреждения</a:t>
+            </a:r>
+            <a:endParaRPr lang="en-US" sz="2000" dirty="0"/>
+          </a:p>
+        </p:txBody>
+      </p:sp>
+      <p:sp>
+        <p:nvSpPr>
+          <p:cNvPr id="13" name="appendix-n-3"/>
+          <p:cNvSpPr/>
+          <p:nvPr/>
+        </p:nvSpPr>
+        <p:spPr>
+          <a:xfrm>
+            <a:off x="548640" y="4937760"/>
+            <a:ext cx="548640" cy="548640"/>
+          </a:xfrm>
+          <a:prstGeom prst="roundRect">
+            <a:avLst>
+              <a:gd name="adj" fmla="val 16667"/>
+            </a:avLst>
+          </a:prstGeom>
+          <a:solidFill>
+            <a:schemeClr val="accent6"/>
+          </a:solidFill>
+          <a:ln/>
+        </p:spPr>
+      </p:sp>
+      <p:sp>
+        <p:nvSpPr>
+          <p:cNvPr id="14" name="Text 12"/>
+          <p:cNvSpPr txBox="1"/>
+          <p:nvPr/>
+        </p:nvSpPr>
+        <p:spPr>
+          <a:xfrm>
+            <a:off x="548640" y="4937760"/>
+            <a:ext cx="548640" cy="548640"/>
+          </a:xfrm>
+          <a:prstGeom prst="rect">
+            <a:avLst/>
+          </a:prstGeom>
+          <a:noFill/>
+          <a:ln/>
+        </p:spPr>
+        <p:txBody>
+          <a:bodyPr wrap="square" lIns="0" tIns="0" rIns="0" bIns="0" rtlCol="0" anchor="ctr"/>
+          <a:lstStyle/>
+          <a:p>
+            <a:pPr algn="ctr" indent="0" marL="0">
+              <a:buNone/>
+            </a:pPr>
+            <a:r>
+              <a:rPr lang="en-US" sz="1600" b="1" dirty="0">
+                <a:solidFill>
+                  <a:schemeClr val="accent5"/>
+                </a:solidFill>
+                <a:latin typeface="+mj-lt" pitchFamily="34" charset="0"/>
+                <a:ea typeface="+mj-lt" pitchFamily="34" charset="-122"/>
+                <a:cs typeface="+mj-lt" pitchFamily="34" charset="-120"/>
+              </a:rPr>
+              <a:t>14</a:t>
+            </a:r>
+            <a:endParaRPr lang="en-US" sz="1600" dirty="0"/>
+          </a:p>
+        </p:txBody>
+      </p:sp>
+      <p:sp>
+        <p:nvSpPr>
           <p:cNvPr id="15" name="Text 13"/>
           <p:cNvSpPr txBox="1"/>
           <p:nvPr/>
@@ -3247,7 +3247,7 @@
                   <a:schemeClr val="bg1"/>
                 </a:solidFill>
               </a:rPr>
-              <a:t>Заблаговременность и честность коридора P10–P90</a:t>
+              <a:t>Коридор P10–P90: попадание факта</a:t>
             </a:r>
             <a:endParaRPr lang="en-US" sz="2000" dirty="0"/>
           </a:p>
@@ -3310,7 +3310,7 @@
                   <a:schemeClr val="tx1"/>
                 </a:solidFill>
               </a:rPr>
-              <a:t>ROC-кривая и калибровка вероятности</a:t>
+              <a:t>Матрица ошибок статусов</a:t>
             </a:r>
             <a:endParaRPr lang="en-US" sz="3400" dirty="0"/>
           </a:p>
@@ -3348,7 +3348,7 @@
                   <a:schemeClr val="tx2"/>
                 </a:solidFill>
               </a:rPr>
-              <a:t>Риск упорядочен верно, но обещанная вероятность выше случившейся частоты</a:t>
+              <a:t>«Повышенный риск» нашёл 8 из 10 разрывов при 75 ложных тревогах</a:t>
             </a:r>
             <a:endParaRPr lang="en-US" sz="1800" dirty="0"/>
           </a:p>
@@ -3390,7 +3390,7 @@
       </p:sp>
       <p:pic>
         <p:nvPicPr>
-          <p:cNvPr id="5" name="Image 0" descr="ROC-кривая с порогами 10% и 50% и калибровка: обещано против случившегося">    </p:cNvPr>
+          <p:cNvPr id="5" name="Image 0" descr="Матрицы ошибок статусов «Повышенный риск» и «Критический» против факта">    </p:cNvPr>
           <p:cNvPicPr>
             <a:picLocks noChangeAspect="1"/>
           </p:cNvPicPr>
@@ -3514,7 +3514,7 @@
                   <a:schemeClr val="tx1"/>
                 </a:solidFill>
               </a:rPr>
-              <a:t>Precision и Recall по порогу вероятности</a:t>
+              <a:t>MAE и RMSE по горизонту прогноза</a:t>
             </a:r>
             <a:endParaRPr lang="en-US" sz="3400" dirty="0"/>
           </a:p>
@@ -3552,7 +3552,7 @@
                   <a:schemeClr val="tx2"/>
                 </a:solidFill>
               </a:rPr>
-              <a:t>Чем выше порог, тем меньше тревог, но и найденных разрывов</a:t>
+              <a:t>Ошибка растёт с горизонтом; в среднем MAE 1,17 млн ₽, RMSE 3,25 млн ₽</a:t>
             </a:r>
             <a:endParaRPr lang="en-US" sz="1800" dirty="0"/>
           </a:p>
@@ -3566,12 +3566,12 @@
         </p:nvSpPr>
         <p:spPr>
           <a:xfrm>
-            <a:off x="1926184" y="1545336"/>
-            <a:ext cx="8339328" cy="4748230"/>
+            <a:off x="493776" y="1865376"/>
+            <a:ext cx="5519776" cy="3159028"/>
           </a:xfrm>
           <a:prstGeom prst="roundRect">
             <a:avLst>
-              <a:gd name="adj" fmla="val 1541"/>
+              <a:gd name="adj" fmla="val 2316"/>
             </a:avLst>
           </a:prstGeom>
           <a:solidFill>
@@ -3594,7 +3594,7 @@
       </p:sp>
       <p:pic>
         <p:nvPicPr>
-          <p:cNvPr id="5" name="Image 0" descr="Precision с 95% интервалом и recall по порогу вероятности от 5 до 95%">    </p:cNvPr>
+          <p:cNvPr id="5" name="Image 0" descr="MAE по дням горизонта для трёх подходов">    </p:cNvPr>
           <p:cNvPicPr>
             <a:picLocks noChangeAspect="1"/>
           </p:cNvPicPr>
@@ -3608,8 +3608,66 @@
         </p:blipFill>
         <p:spPr>
           <a:xfrm>
-            <a:off x="1981048" y="1600200"/>
-            <a:ext cx="8229600" cy="4638502"/>
+            <a:off x="548640" y="1920240"/>
+            <a:ext cx="5410048" cy="3049300"/>
+          </a:xfrm>
+          <a:prstGeom prst="rect">
+            <a:avLst/>
+          </a:prstGeom>
+        </p:spPr>
+      </p:pic>
+      <p:sp>
+        <p:nvSpPr>
+          <p:cNvPr id="6" name="Shape 3"/>
+          <p:cNvSpPr/>
+          <p:nvPr/>
+        </p:nvSpPr>
+        <p:spPr>
+          <a:xfrm>
+            <a:off x="6178144" y="1865376"/>
+            <a:ext cx="5519776" cy="3159028"/>
+          </a:xfrm>
+          <a:prstGeom prst="roundRect">
+            <a:avLst>
+              <a:gd name="adj" fmla="val 2316"/>
+            </a:avLst>
+          </a:prstGeom>
+          <a:solidFill>
+            <a:schemeClr val="bg1"/>
+          </a:solidFill>
+          <a:ln w="12700">
+            <a:solidFill>
+              <a:schemeClr val="bg2"/>
+            </a:solidFill>
+            <a:prstDash val="solid"/>
+          </a:ln>
+          <a:effectLst>
+            <a:outerShdw sx="100000" sy="100000" kx="0" ky="0" algn="bl" rotWithShape="0" blurRad="127000" dist="38100" dir="5400000">
+              <a:srgbClr val="0F172A">
+                <a:alpha val="16000"/>
+              </a:srgbClr>
+            </a:outerShdw>
+          </a:effectLst>
+        </p:spPr>
+      </p:sp>
+      <p:pic>
+        <p:nvPicPr>
+          <p:cNvPr id="7" name="Image 1" descr="RMSE по дням горизонта для трёх подходов">    </p:cNvPr>
+          <p:cNvPicPr>
+            <a:picLocks noChangeAspect="1"/>
+          </p:cNvPicPr>
+          <p:nvPr/>
+        </p:nvPicPr>
+        <p:blipFill>
+          <a:blip r:embed="rId2"/>
+          <a:stretch>
+            <a:fillRect/>
+          </a:stretch>
+        </p:blipFill>
+        <p:spPr>
+          <a:xfrm>
+            <a:off x="6233008" y="1920240"/>
+            <a:ext cx="5410048" cy="3049300"/>
           </a:xfrm>
           <a:prstGeom prst="rect">
             <a:avLst/>
@@ -3718,7 +3776,7 @@
                   <a:schemeClr val="tx1"/>
                 </a:solidFill>
               </a:rPr>
-              <a:t>MAE и RMSE по горизонту прогноза</a:t>
+              <a:t>Заблаговременность предупреждения</a:t>
             </a:r>
             <a:endParaRPr lang="en-US" sz="3400" dirty="0"/>
           </a:p>
@@ -3756,7 +3814,7 @@
                   <a:schemeClr val="tx2"/>
                 </a:solidFill>
               </a:rPr>
-              <a:t>Ошибка растёт с горизонтом; модель на уровне наивной и лучше линейного тренда</a:t>
+              <a:t>Найденные разрывы видны в среднем за 21,5 дня</a:t>
             </a:r>
             <a:endParaRPr lang="en-US" sz="1800" dirty="0"/>
           </a:p>
@@ -3798,7 +3856,7 @@
       </p:sp>
       <p:pic>
         <p:nvPicPr>
-          <p:cNvPr id="5" name="Image 0" descr="MAE по дням горизонта для трёх подходов">    </p:cNvPr>
+          <p:cNvPr id="5" name="Image 0" descr="Дни от прогноза до первого дня с минусом для найденных и пропущенных разрывов">    </p:cNvPr>
           <p:cNvPicPr>
             <a:picLocks noChangeAspect="1"/>
           </p:cNvPicPr>
@@ -3922,7 +3980,7 @@
                   <a:schemeClr val="tx1"/>
                 </a:solidFill>
               </a:rPr>
-              <a:t>Заблаговременность и честность коридора</a:t>
+              <a:t>Коридор P10–P90: попадание факта</a:t>
             </a:r>
             <a:endParaRPr lang="en-US" sz="3400" dirty="0"/>
           </a:p>
@@ -3960,7 +4018,7 @@
                   <a:schemeClr val="tx2"/>
                 </a:solidFill>
               </a:rPr>
-              <a:t>Предупреждение в среднем за 21,5 дня; факт внутри P10–P90 в 76,9% точек</a:t>
+              <a:t>Факт внутри коридора в 76,9% точек при ожидаемых 80%</a:t>
             </a:r>
             <a:endParaRPr lang="en-US" sz="1800" dirty="0"/>
           </a:p>
@@ -3974,12 +4032,12 @@
         </p:nvSpPr>
         <p:spPr>
           <a:xfrm>
-            <a:off x="493776" y="1865376"/>
-            <a:ext cx="5519776" cy="3159028"/>
+            <a:off x="1926184" y="1545336"/>
+            <a:ext cx="8339328" cy="4748230"/>
           </a:xfrm>
           <a:prstGeom prst="roundRect">
             <a:avLst>
-              <a:gd name="adj" fmla="val 2316"/>
+              <a:gd name="adj" fmla="val 1541"/>
             </a:avLst>
           </a:prstGeom>
           <a:solidFill>
@@ -4002,7 +4060,7 @@
       </p:sp>
       <p:pic>
         <p:nvPicPr>
-          <p:cNvPr id="5" name="Image 0" descr="Дни от прогноза до первого дня с минусом для найденных и пропущенных разрывов">    </p:cNvPr>
+          <p:cNvPr id="5" name="Image 0" descr="Доля фактов внутри коридора P10–P90 по дням горизонта">    </p:cNvPr>
           <p:cNvPicPr>
             <a:picLocks noChangeAspect="1"/>
           </p:cNvPicPr>
@@ -4016,66 +4074,8 @@
         </p:blipFill>
         <p:spPr>
           <a:xfrm>
-            <a:off x="548640" y="1920240"/>
-            <a:ext cx="5410048" cy="3049300"/>
-          </a:xfrm>
-          <a:prstGeom prst="rect">
-            <a:avLst/>
-          </a:prstGeom>
-        </p:spPr>
-      </p:pic>
-      <p:sp>
-        <p:nvSpPr>
-          <p:cNvPr id="6" name="Shape 3"/>
-          <p:cNvSpPr/>
-          <p:nvPr/>
-        </p:nvSpPr>
-        <p:spPr>
-          <a:xfrm>
-            <a:off x="6178144" y="1865376"/>
-            <a:ext cx="5519776" cy="3159028"/>
-          </a:xfrm>
-          <a:prstGeom prst="roundRect">
-            <a:avLst>
-              <a:gd name="adj" fmla="val 2316"/>
-            </a:avLst>
-          </a:prstGeom>
-          <a:solidFill>
-            <a:schemeClr val="bg1"/>
-          </a:solidFill>
-          <a:ln w="12700">
-            <a:solidFill>
-              <a:schemeClr val="bg2"/>
-            </a:solidFill>
-            <a:prstDash val="solid"/>
-          </a:ln>
-          <a:effectLst>
-            <a:outerShdw sx="100000" sy="100000" kx="0" ky="0" algn="bl" rotWithShape="0" blurRad="127000" dist="38100" dir="5400000">
-              <a:srgbClr val="0F172A">
-                <a:alpha val="16000"/>
-              </a:srgbClr>
-            </a:outerShdw>
-          </a:effectLst>
-        </p:spPr>
-      </p:sp>
-      <p:pic>
-        <p:nvPicPr>
-          <p:cNvPr id="7" name="Image 1" descr="Доля фактов внутри коридора P10–P90 по дням горизонта">    </p:cNvPr>
-          <p:cNvPicPr>
-            <a:picLocks noChangeAspect="1"/>
-          </p:cNvPicPr>
-          <p:nvPr/>
-        </p:nvPicPr>
-        <p:blipFill>
-          <a:blip r:embed="rId2"/>
-          <a:stretch>
-            <a:fillRect/>
-          </a:stretch>
-        </p:blipFill>
-        <p:spPr>
-          <a:xfrm>
-            <a:off x="6233008" y="1920240"/>
-            <a:ext cx="5410048" cy="3049300"/>
+            <a:off x="1981048" y="1600200"/>
+            <a:ext cx="8229600" cy="4638502"/>
           </a:xfrm>
           <a:prstGeom prst="rect">
             <a:avLst/>

</xml_diff>